<commit_message>
Update Myriad iOS Xcode subproject reference
</commit_message>
<xml_diff>
--- a/Myriad_Project_Presentation.pptx
+++ b/Myriad_Project_Presentation.pptx
@@ -13,12 +13,8 @@
     <p:sldId id="261" r:id="rId12"/>
     <p:sldId id="262" r:id="rId13"/>
     <p:sldId id="263" r:id="rId14"/>
-    <p:sldId id="264" r:id="rId15"/>
-    <p:sldId id="265" r:id="rId16"/>
-    <p:sldId id="266" r:id="rId17"/>
-    <p:sldId id="267" r:id="rId18"/>
   </p:sldIdLst>
-  <p:sldSz cx="9144000" cy="6858000" type="screen4x3"/>
+  <p:sldSz cx="12191695" cy="6858000" type="screen4x3"/>
   <p:notesSz cx="6858000" cy="9144000"/>
   <p:defaultTextStyle>
     <a:defPPr>
@@ -3095,7 +3091,7 @@
     <p:bg>
       <p:bgPr>
         <a:solidFill>
-          <a:srgbClr val="F7FBFF"/>
+          <a:srgbClr val="F2F7FC"/>
         </a:solidFill>
         <a:effectLst/>
       </p:bgPr>
@@ -3115,8 +3111,8 @@
         </p:nvSpPr>
         <p:spPr>
           <a:xfrm>
-            <a:off x="640080" y="365760"/>
-            <a:ext cx="10789920" cy="1097280"/>
+            <a:off x="502920" y="320040"/>
+            <a:ext cx="11155680" cy="731520"/>
           </a:xfrm>
           <a:prstGeom prst="rect">
             <a:avLst/>
@@ -3130,7 +3126,7 @@
           <a:lstStyle/>
           <a:p>
             <a:r>
-              <a:rPr sz="3800" b="1">
+              <a:rPr sz="3400" b="1">
                 <a:solidFill>
                   <a:srgbClr val="0D2A3E"/>
                 </a:solidFill>
@@ -3140,14 +3136,14 @@
           </a:p>
           <a:p>
             <a:pPr>
-              <a:defRPr sz="1600">
-                <a:solidFill>
-                  <a:srgbClr val="5A5A5A"/>
+              <a:defRPr sz="1400">
+                <a:solidFill>
+                  <a:srgbClr val="5C5C5C"/>
                 </a:solidFill>
               </a:defRPr>
             </a:pPr>
             <a:r>
-              <a:t>AI-enabled, privacy-first mindful habit tracking across desktop and iOS</a:t>
+              <a:t>Privacy-first mindful habit tracking across desktop and iOS</a:t>
             </a:r>
           </a:p>
         </p:txBody>
@@ -3160,8 +3156,100 @@
         </p:nvSpPr>
         <p:spPr>
           <a:xfrm>
-            <a:off x="822960" y="2194560"/>
-            <a:ext cx="10972800" cy="4389120"/>
+            <a:off x="777240" y="1645920"/>
+            <a:ext cx="5212080" cy="5303520"/>
+          </a:xfrm>
+          <a:prstGeom prst="rect">
+            <a:avLst/>
+          </a:prstGeom>
+          <a:noFill/>
+        </p:spPr>
+        <p:txBody>
+          <a:bodyPr wrap="square">
+            <a:spAutoFit/>
+          </a:bodyPr>
+          <a:lstStyle/>
+          <a:p>
+            <a:pPr>
+              <a:spcAft>
+                <a:spcPts val="1000"/>
+              </a:spcAft>
+              <a:defRPr sz="2200">
+                <a:solidFill>
+                  <a:srgbClr val="2D2D2D"/>
+                </a:solidFill>
+              </a:defRPr>
+            </a:pPr>
+            <a:r>
+              <a:t>Final Year Project Presentation</a:t>
+            </a:r>
+          </a:p>
+          <a:p>
+            <a:pPr>
+              <a:spcAft>
+                <a:spcPts val="1000"/>
+              </a:spcAft>
+              <a:defRPr sz="2200">
+                <a:solidFill>
+                  <a:srgbClr val="2D2D2D"/>
+                </a:solidFill>
+              </a:defRPr>
+            </a:pPr>
+            <a:r>
+              <a:t>Said Osman</a:t>
+            </a:r>
+          </a:p>
+          <a:p>
+            <a:pPr>
+              <a:spcAft>
+                <a:spcPts val="1000"/>
+              </a:spcAft>
+              <a:defRPr sz="2200">
+                <a:solidFill>
+                  <a:srgbClr val="2D2D2D"/>
+                </a:solidFill>
+              </a:defRPr>
+            </a:pPr>
+            <a:r>
+              <a:t>Local-first analytics, behavior change, adaptive relapse prevention</a:t>
+            </a:r>
+          </a:p>
+        </p:txBody>
+      </p:sp>
+      <p:pic>
+        <p:nvPicPr>
+          <p:cNvPr id="4" name="Picture 3" descr="myriad_home.png"/>
+          <p:cNvPicPr>
+            <a:picLocks noChangeAspect="1"/>
+          </p:cNvPicPr>
+          <p:nvPr/>
+        </p:nvPicPr>
+        <p:blipFill>
+          <a:blip r:embed="rId2"/>
+          <a:stretch>
+            <a:fillRect/>
+          </a:stretch>
+        </p:blipFill>
+        <p:spPr>
+          <a:xfrm>
+            <a:off x="5989320" y="1051560"/>
+            <a:ext cx="5394960" cy="3371850"/>
+          </a:xfrm>
+          <a:prstGeom prst="rect">
+            <a:avLst/>
+          </a:prstGeom>
+        </p:spPr>
+      </p:pic>
+      <p:sp>
+        <p:nvSpPr>
+          <p:cNvPr id="5" name="TextBox 4"/>
+          <p:cNvSpPr txBox="1"/>
+          <p:nvPr/>
+        </p:nvSpPr>
+        <p:spPr>
+          <a:xfrm>
+            <a:off x="5989320" y="5394960"/>
+            <a:ext cx="5394960" cy="320040"/>
           </a:xfrm>
           <a:prstGeom prst="rect">
             <a:avLst/>
@@ -3174,62 +3262,29 @@
           </a:bodyPr>
           <a:lstStyle/>
           <a:p>
-            <a:pPr>
-              <a:spcAft>
-                <a:spcPts val="1200"/>
-              </a:spcAft>
-              <a:defRPr sz="2400">
-                <a:solidFill>
-                  <a:srgbClr val="2D2D2D"/>
+            <a:pPr algn="l">
+              <a:defRPr sz="1100">
+                <a:solidFill>
+                  <a:srgbClr val="5C5C5C"/>
                 </a:solidFill>
               </a:defRPr>
             </a:pPr>
             <a:r>
-              <a:t>Final Year Project Presentation</a:t>
-            </a:r>
-          </a:p>
-          <a:p>
-            <a:pPr>
-              <a:spcAft>
-                <a:spcPts val="1200"/>
-              </a:spcAft>
-              <a:defRPr sz="2400">
-                <a:solidFill>
-                  <a:srgbClr val="2D2D2D"/>
-                </a:solidFill>
-              </a:defRPr>
-            </a:pPr>
-            <a:r>
-              <a:t>Said Osman</a:t>
-            </a:r>
-          </a:p>
-          <a:p>
-            <a:pPr>
-              <a:spcAft>
-                <a:spcPts val="1200"/>
-              </a:spcAft>
-              <a:defRPr sz="2400">
-                <a:solidFill>
-                  <a:srgbClr val="2D2D2D"/>
-                </a:solidFill>
-              </a:defRPr>
-            </a:pPr>
-            <a:r>
-              <a:t>Focus: privacy, behavior change, adaptive relapse prevention</a:t>
-            </a:r>
-          </a:p>
-        </p:txBody>
-      </p:sp>
-      <p:sp>
-        <p:nvSpPr>
-          <p:cNvPr id="4" name="Rectangle 3"/>
+              <a:t>Home dashboard screenshot</a:t>
+            </a:r>
+          </a:p>
+        </p:txBody>
+      </p:sp>
+      <p:sp>
+        <p:nvSpPr>
+          <p:cNvPr id="6" name="Rectangle 5"/>
           <p:cNvSpPr/>
           <p:nvPr/>
         </p:nvSpPr>
         <p:spPr>
           <a:xfrm>
-            <a:off x="548640" y="6263640"/>
-            <a:ext cx="11064240" cy="18288"/>
+            <a:off x="502920" y="6309360"/>
+            <a:ext cx="11201400" cy="27432"/>
           </a:xfrm>
           <a:prstGeom prst="rect">
             <a:avLst/>
@@ -3265,14 +3320,14 @@
       </p:sp>
       <p:sp>
         <p:nvSpPr>
-          <p:cNvPr id="5" name="TextBox 4"/>
+          <p:cNvPr id="7" name="TextBox 6"/>
           <p:cNvSpPr txBox="1"/>
           <p:nvPr/>
         </p:nvSpPr>
         <p:spPr>
           <a:xfrm>
-            <a:off x="640080" y="6355080"/>
-            <a:ext cx="7772400" cy="365760"/>
+            <a:off x="502920" y="6400800"/>
+            <a:ext cx="6400800" cy="228600"/>
           </a:xfrm>
           <a:prstGeom prst="rect">
             <a:avLst/>
@@ -3286,28 +3341,28 @@
           <a:lstStyle/>
           <a:p>
             <a:pPr>
-              <a:defRPr sz="1200">
-                <a:solidFill>
-                  <a:srgbClr val="5A5A5A"/>
+              <a:defRPr sz="1000">
+                <a:solidFill>
+                  <a:srgbClr val="5C5C5C"/>
                 </a:solidFill>
               </a:defRPr>
             </a:pPr>
             <a:r>
-              <a:t>Myriad | Privacy-first mindful habit tracking</a:t>
-            </a:r>
-          </a:p>
-        </p:txBody>
-      </p:sp>
-      <p:sp>
-        <p:nvSpPr>
-          <p:cNvPr id="6" name="TextBox 5"/>
+              <a:t>Myriad</a:t>
+            </a:r>
+          </a:p>
+        </p:txBody>
+      </p:sp>
+      <p:sp>
+        <p:nvSpPr>
+          <p:cNvPr id="8" name="TextBox 7"/>
           <p:cNvSpPr txBox="1"/>
           <p:nvPr/>
         </p:nvSpPr>
         <p:spPr>
           <a:xfrm>
-            <a:off x="8869680" y="6355080"/>
-            <a:ext cx="2651760" cy="365760"/>
+            <a:off x="9966960" y="6400800"/>
+            <a:ext cx="1737360" cy="228600"/>
           </a:xfrm>
           <a:prstGeom prst="rect">
             <a:avLst/>
@@ -3321,764 +3376,14 @@
           <a:lstStyle/>
           <a:p>
             <a:pPr algn="ctr">
-              <a:defRPr sz="1200">
-                <a:solidFill>
-                  <a:srgbClr val="5A5A5A"/>
+              <a:defRPr sz="1000">
+                <a:solidFill>
+                  <a:srgbClr val="5C5C5C"/>
                 </a:solidFill>
               </a:defRPr>
             </a:pPr>
             <a:r>
-              <a:t>15 Apr 2026</a:t>
-            </a:r>
-          </a:p>
-        </p:txBody>
-      </p:sp>
-    </p:spTree>
-  </p:cSld>
-  <p:clrMapOvr>
-    <a:masterClrMapping/>
-  </p:clrMapOvr>
-</p:sld>
-</file>
-
-<file path=ppt/slides/slide10.xml><?xml version="1.0" encoding="utf-8"?>
-<p:sld xmlns:a="http://schemas.openxmlformats.org/drawingml/2006/main" xmlns:p="http://schemas.openxmlformats.org/presentationml/2006/main" xmlns:r="http://schemas.openxmlformats.org/officeDocument/2006/relationships">
-  <p:cSld>
-    <p:bg>
-      <p:bgPr>
-        <a:solidFill>
-          <a:srgbClr val="FFFFF5"/>
-        </a:solidFill>
-        <a:effectLst/>
-      </p:bgPr>
-    </p:bg>
-    <p:spTree>
-      <p:nvGrpSpPr>
-        <p:cNvPr id="1" name=""/>
-        <p:cNvGrpSpPr/>
-        <p:nvPr/>
-      </p:nvGrpSpPr>
-      <p:grpSpPr/>
-      <p:sp>
-        <p:nvSpPr>
-          <p:cNvPr id="2" name="TextBox 1"/>
-          <p:cNvSpPr txBox="1"/>
-          <p:nvPr/>
-        </p:nvSpPr>
-        <p:spPr>
-          <a:xfrm>
-            <a:off x="640080" y="365760"/>
-            <a:ext cx="10789920" cy="1097280"/>
-          </a:xfrm>
-          <a:prstGeom prst="rect">
-            <a:avLst/>
-          </a:prstGeom>
-          <a:noFill/>
-        </p:spPr>
-        <p:txBody>
-          <a:bodyPr wrap="none">
-            <a:spAutoFit/>
-          </a:bodyPr>
-          <a:lstStyle/>
-          <a:p>
-            <a:r>
-              <a:rPr sz="3800" b="1">
-                <a:solidFill>
-                  <a:srgbClr val="0D2A3E"/>
-                </a:solidFill>
-              </a:rPr>
-              <a:t>Limitations and Next Steps</a:t>
-            </a:r>
-          </a:p>
-        </p:txBody>
-      </p:sp>
-      <p:sp>
-        <p:nvSpPr>
-          <p:cNvPr id="3" name="TextBox 2"/>
-          <p:cNvSpPr txBox="1"/>
-          <p:nvPr/>
-        </p:nvSpPr>
-        <p:spPr>
-          <a:xfrm>
-            <a:off x="822960" y="1645920"/>
-            <a:ext cx="10972800" cy="4389120"/>
-          </a:xfrm>
-          <a:prstGeom prst="rect">
-            <a:avLst/>
-          </a:prstGeom>
-          <a:noFill/>
-        </p:spPr>
-        <p:txBody>
-          <a:bodyPr wrap="none">
-            <a:spAutoFit/>
-          </a:bodyPr>
-          <a:lstStyle/>
-          <a:p>
-            <a:pPr>
-              <a:spcAft>
-                <a:spcPts val="1200"/>
-              </a:spcAft>
-              <a:defRPr sz="2200">
-                <a:solidFill>
-                  <a:srgbClr val="2D2D2D"/>
-                </a:solidFill>
-              </a:defRPr>
-            </a:pPr>
-            <a:r>
-              <a:t>Current usability sample size is small; larger study needed.</a:t>
-            </a:r>
-          </a:p>
-          <a:p>
-            <a:pPr>
-              <a:spcAft>
-                <a:spcPts val="1200"/>
-              </a:spcAft>
-              <a:defRPr sz="2200">
-                <a:solidFill>
-                  <a:srgbClr val="2D2D2D"/>
-                </a:solidFill>
-              </a:defRPr>
-            </a:pPr>
-            <a:r>
-              <a:t>Risk model can be improved with longitudinal calibration and personalization.</a:t>
-            </a:r>
-          </a:p>
-          <a:p>
-            <a:pPr>
-              <a:spcAft>
-                <a:spcPts val="1200"/>
-              </a:spcAft>
-              <a:defRPr sz="2200">
-                <a:solidFill>
-                  <a:srgbClr val="2D2D2D"/>
-                </a:solidFill>
-              </a:defRPr>
-            </a:pPr>
-            <a:r>
-              <a:t>Next: richer intervention content, real-time coaching, and longitudinal outcomes.</a:t>
-            </a:r>
-          </a:p>
-          <a:p>
-            <a:pPr>
-              <a:spcAft>
-                <a:spcPts val="1200"/>
-              </a:spcAft>
-              <a:defRPr sz="2200">
-                <a:solidFill>
-                  <a:srgbClr val="2D2D2D"/>
-                </a:solidFill>
-              </a:defRPr>
-            </a:pPr>
-            <a:r>
-              <a:t>Potential publication direction: privacy-preserving behavior change systems.</a:t>
-            </a:r>
-          </a:p>
-        </p:txBody>
-      </p:sp>
-      <p:sp>
-        <p:nvSpPr>
-          <p:cNvPr id="4" name="Rectangle 3"/>
-          <p:cNvSpPr/>
-          <p:nvPr/>
-        </p:nvSpPr>
-        <p:spPr>
-          <a:xfrm>
-            <a:off x="548640" y="6263640"/>
-            <a:ext cx="11064240" cy="18288"/>
-          </a:xfrm>
-          <a:prstGeom prst="rect">
-            <a:avLst/>
-          </a:prstGeom>
-          <a:solidFill>
-            <a:srgbClr val="1A86D6"/>
-          </a:solidFill>
-          <a:ln>
-            <a:noFill/>
-          </a:ln>
-        </p:spPr>
-        <p:style>
-          <a:lnRef idx="1">
-            <a:schemeClr val="accent1"/>
-          </a:lnRef>
-          <a:fillRef idx="3">
-            <a:schemeClr val="accent1"/>
-          </a:fillRef>
-          <a:effectRef idx="2">
-            <a:schemeClr val="accent1"/>
-          </a:effectRef>
-          <a:fontRef idx="minor">
-            <a:schemeClr val="lt1"/>
-          </a:fontRef>
-        </p:style>
-        <p:txBody>
-          <a:bodyPr rtlCol="0" anchor="ctr"/>
-          <a:lstStyle/>
-          <a:p>
-            <a:pPr algn="ctr"/>
-          </a:p>
-        </p:txBody>
-      </p:sp>
-      <p:sp>
-        <p:nvSpPr>
-          <p:cNvPr id="5" name="TextBox 4"/>
-          <p:cNvSpPr txBox="1"/>
-          <p:nvPr/>
-        </p:nvSpPr>
-        <p:spPr>
-          <a:xfrm>
-            <a:off x="640080" y="6355080"/>
-            <a:ext cx="7772400" cy="365760"/>
-          </a:xfrm>
-          <a:prstGeom prst="rect">
-            <a:avLst/>
-          </a:prstGeom>
-          <a:noFill/>
-        </p:spPr>
-        <p:txBody>
-          <a:bodyPr wrap="none">
-            <a:spAutoFit/>
-          </a:bodyPr>
-          <a:lstStyle/>
-          <a:p>
-            <a:pPr>
-              <a:defRPr sz="1200">
-                <a:solidFill>
-                  <a:srgbClr val="5A5A5A"/>
-                </a:solidFill>
-              </a:defRPr>
-            </a:pPr>
-            <a:r>
-              <a:t>Myriad | Privacy-first mindful habit tracking</a:t>
-            </a:r>
-          </a:p>
-        </p:txBody>
-      </p:sp>
-      <p:sp>
-        <p:nvSpPr>
-          <p:cNvPr id="6" name="TextBox 5"/>
-          <p:cNvSpPr txBox="1"/>
-          <p:nvPr/>
-        </p:nvSpPr>
-        <p:spPr>
-          <a:xfrm>
-            <a:off x="8869680" y="6355080"/>
-            <a:ext cx="2651760" cy="365760"/>
-          </a:xfrm>
-          <a:prstGeom prst="rect">
-            <a:avLst/>
-          </a:prstGeom>
-          <a:noFill/>
-        </p:spPr>
-        <p:txBody>
-          <a:bodyPr wrap="none">
-            <a:spAutoFit/>
-          </a:bodyPr>
-          <a:lstStyle/>
-          <a:p>
-            <a:pPr algn="ctr">
-              <a:defRPr sz="1200">
-                <a:solidFill>
-                  <a:srgbClr val="5A5A5A"/>
-                </a:solidFill>
-              </a:defRPr>
-            </a:pPr>
-            <a:r>
-              <a:t>15 Apr 2026</a:t>
-            </a:r>
-          </a:p>
-        </p:txBody>
-      </p:sp>
-    </p:spTree>
-  </p:cSld>
-  <p:clrMapOvr>
-    <a:masterClrMapping/>
-  </p:clrMapOvr>
-</p:sld>
-</file>
-
-<file path=ppt/slides/slide11.xml><?xml version="1.0" encoding="utf-8"?>
-<p:sld xmlns:a="http://schemas.openxmlformats.org/drawingml/2006/main" xmlns:p="http://schemas.openxmlformats.org/presentationml/2006/main" xmlns:r="http://schemas.openxmlformats.org/officeDocument/2006/relationships">
-  <p:cSld>
-    <p:bg>
-      <p:bgPr>
-        <a:solidFill>
-          <a:srgbClr val="F5FFFF"/>
-        </a:solidFill>
-        <a:effectLst/>
-      </p:bgPr>
-    </p:bg>
-    <p:spTree>
-      <p:nvGrpSpPr>
-        <p:cNvPr id="1" name=""/>
-        <p:cNvGrpSpPr/>
-        <p:nvPr/>
-      </p:nvGrpSpPr>
-      <p:grpSpPr/>
-      <p:sp>
-        <p:nvSpPr>
-          <p:cNvPr id="2" name="TextBox 1"/>
-          <p:cNvSpPr txBox="1"/>
-          <p:nvPr/>
-        </p:nvSpPr>
-        <p:spPr>
-          <a:xfrm>
-            <a:off x="640080" y="365760"/>
-            <a:ext cx="10789920" cy="1097280"/>
-          </a:xfrm>
-          <a:prstGeom prst="rect">
-            <a:avLst/>
-          </a:prstGeom>
-          <a:noFill/>
-        </p:spPr>
-        <p:txBody>
-          <a:bodyPr wrap="none">
-            <a:spAutoFit/>
-          </a:bodyPr>
-          <a:lstStyle/>
-          <a:p>
-            <a:r>
-              <a:rPr sz="3800" b="1">
-                <a:solidFill>
-                  <a:srgbClr val="0D2A3E"/>
-                </a:solidFill>
-              </a:rPr>
-              <a:t>Live Demo Flow</a:t>
-            </a:r>
-          </a:p>
-        </p:txBody>
-      </p:sp>
-      <p:sp>
-        <p:nvSpPr>
-          <p:cNvPr id="3" name="TextBox 2"/>
-          <p:cNvSpPr txBox="1"/>
-          <p:nvPr/>
-        </p:nvSpPr>
-        <p:spPr>
-          <a:xfrm>
-            <a:off x="822960" y="1645920"/>
-            <a:ext cx="10972800" cy="4389120"/>
-          </a:xfrm>
-          <a:prstGeom prst="rect">
-            <a:avLst/>
-          </a:prstGeom>
-          <a:noFill/>
-        </p:spPr>
-        <p:txBody>
-          <a:bodyPr wrap="none">
-            <a:spAutoFit/>
-          </a:bodyPr>
-          <a:lstStyle/>
-          <a:p>
-            <a:pPr>
-              <a:spcAft>
-                <a:spcPts val="1200"/>
-              </a:spcAft>
-              <a:defRPr sz="2000">
-                <a:solidFill>
-                  <a:srgbClr val="2D2D2D"/>
-                </a:solidFill>
-              </a:defRPr>
-            </a:pPr>
-            <a:r>
-              <a:t>1) Register/login and import sample events</a:t>
-            </a:r>
-          </a:p>
-          <a:p>
-            <a:pPr>
-              <a:spcAft>
-                <a:spcPts val="1200"/>
-              </a:spcAft>
-              <a:defRPr sz="2000">
-                <a:solidFill>
-                  <a:srgbClr val="2D2D2D"/>
-                </a:solidFill>
-              </a:defRPr>
-            </a:pPr>
-            <a:r>
-              <a:t>2) Create habit goal and inspect progress status</a:t>
-            </a:r>
-          </a:p>
-          <a:p>
-            <a:pPr>
-              <a:spcAft>
-                <a:spcPts val="1200"/>
-              </a:spcAft>
-              <a:defRPr sz="2000">
-                <a:solidFill>
-                  <a:srgbClr val="2D2D2D"/>
-                </a:solidFill>
-              </a:defRPr>
-            </a:pPr>
-            <a:r>
-              <a:t>3) Show relapse risk breakdown and intervention plan</a:t>
-            </a:r>
-          </a:p>
-          <a:p>
-            <a:pPr>
-              <a:spcAft>
-                <a:spcPts val="1200"/>
-              </a:spcAft>
-              <a:defRPr sz="2000">
-                <a:solidFill>
-                  <a:srgbClr val="2D2D2D"/>
-                </a:solidFill>
-              </a:defRPr>
-            </a:pPr>
-            <a:r>
-              <a:t>4) Trigger/observe nudge behavior near goal limits</a:t>
-            </a:r>
-          </a:p>
-          <a:p>
-            <a:pPr>
-              <a:spcAft>
-                <a:spcPts val="1200"/>
-              </a:spcAft>
-              <a:defRPr sz="2000">
-                <a:solidFill>
-                  <a:srgbClr val="2D2D2D"/>
-                </a:solidFill>
-              </a:defRPr>
-            </a:pPr>
-            <a:r>
-              <a:t>5) Show privacy warning and data deletion pathway</a:t>
-            </a:r>
-          </a:p>
-        </p:txBody>
-      </p:sp>
-      <p:sp>
-        <p:nvSpPr>
-          <p:cNvPr id="4" name="Rectangle 3"/>
-          <p:cNvSpPr/>
-          <p:nvPr/>
-        </p:nvSpPr>
-        <p:spPr>
-          <a:xfrm>
-            <a:off x="548640" y="6263640"/>
-            <a:ext cx="11064240" cy="18288"/>
-          </a:xfrm>
-          <a:prstGeom prst="rect">
-            <a:avLst/>
-          </a:prstGeom>
-          <a:solidFill>
-            <a:srgbClr val="1A86D6"/>
-          </a:solidFill>
-          <a:ln>
-            <a:noFill/>
-          </a:ln>
-        </p:spPr>
-        <p:style>
-          <a:lnRef idx="1">
-            <a:schemeClr val="accent1"/>
-          </a:lnRef>
-          <a:fillRef idx="3">
-            <a:schemeClr val="accent1"/>
-          </a:fillRef>
-          <a:effectRef idx="2">
-            <a:schemeClr val="accent1"/>
-          </a:effectRef>
-          <a:fontRef idx="minor">
-            <a:schemeClr val="lt1"/>
-          </a:fontRef>
-        </p:style>
-        <p:txBody>
-          <a:bodyPr rtlCol="0" anchor="ctr"/>
-          <a:lstStyle/>
-          <a:p>
-            <a:pPr algn="ctr"/>
-          </a:p>
-        </p:txBody>
-      </p:sp>
-      <p:sp>
-        <p:nvSpPr>
-          <p:cNvPr id="5" name="TextBox 4"/>
-          <p:cNvSpPr txBox="1"/>
-          <p:nvPr/>
-        </p:nvSpPr>
-        <p:spPr>
-          <a:xfrm>
-            <a:off x="640080" y="6355080"/>
-            <a:ext cx="7772400" cy="365760"/>
-          </a:xfrm>
-          <a:prstGeom prst="rect">
-            <a:avLst/>
-          </a:prstGeom>
-          <a:noFill/>
-        </p:spPr>
-        <p:txBody>
-          <a:bodyPr wrap="none">
-            <a:spAutoFit/>
-          </a:bodyPr>
-          <a:lstStyle/>
-          <a:p>
-            <a:pPr>
-              <a:defRPr sz="1200">
-                <a:solidFill>
-                  <a:srgbClr val="5A5A5A"/>
-                </a:solidFill>
-              </a:defRPr>
-            </a:pPr>
-            <a:r>
-              <a:t>Myriad | Privacy-first mindful habit tracking</a:t>
-            </a:r>
-          </a:p>
-        </p:txBody>
-      </p:sp>
-      <p:sp>
-        <p:nvSpPr>
-          <p:cNvPr id="6" name="TextBox 5"/>
-          <p:cNvSpPr txBox="1"/>
-          <p:nvPr/>
-        </p:nvSpPr>
-        <p:spPr>
-          <a:xfrm>
-            <a:off x="8869680" y="6355080"/>
-            <a:ext cx="2651760" cy="365760"/>
-          </a:xfrm>
-          <a:prstGeom prst="rect">
-            <a:avLst/>
-          </a:prstGeom>
-          <a:noFill/>
-        </p:spPr>
-        <p:txBody>
-          <a:bodyPr wrap="none">
-            <a:spAutoFit/>
-          </a:bodyPr>
-          <a:lstStyle/>
-          <a:p>
-            <a:pPr algn="ctr">
-              <a:defRPr sz="1200">
-                <a:solidFill>
-                  <a:srgbClr val="5A5A5A"/>
-                </a:solidFill>
-              </a:defRPr>
-            </a:pPr>
-            <a:r>
-              <a:t>15 Apr 2026</a:t>
-            </a:r>
-          </a:p>
-        </p:txBody>
-      </p:sp>
-    </p:spTree>
-  </p:cSld>
-  <p:clrMapOvr>
-    <a:masterClrMapping/>
-  </p:clrMapOvr>
-</p:sld>
-</file>
-
-<file path=ppt/slides/slide12.xml><?xml version="1.0" encoding="utf-8"?>
-<p:sld xmlns:a="http://schemas.openxmlformats.org/drawingml/2006/main" xmlns:p="http://schemas.openxmlformats.org/presentationml/2006/main" xmlns:r="http://schemas.openxmlformats.org/officeDocument/2006/relationships">
-  <p:cSld>
-    <p:bg>
-      <p:bgPr>
-        <a:solidFill>
-          <a:srgbClr val="F4F8FC"/>
-        </a:solidFill>
-        <a:effectLst/>
-      </p:bgPr>
-    </p:bg>
-    <p:spTree>
-      <p:nvGrpSpPr>
-        <p:cNvPr id="1" name=""/>
-        <p:cNvGrpSpPr/>
-        <p:nvPr/>
-      </p:nvGrpSpPr>
-      <p:grpSpPr/>
-      <p:sp>
-        <p:nvSpPr>
-          <p:cNvPr id="2" name="TextBox 1"/>
-          <p:cNvSpPr txBox="1"/>
-          <p:nvPr/>
-        </p:nvSpPr>
-        <p:spPr>
-          <a:xfrm>
-            <a:off x="640080" y="365760"/>
-            <a:ext cx="10789920" cy="1097280"/>
-          </a:xfrm>
-          <a:prstGeom prst="rect">
-            <a:avLst/>
-          </a:prstGeom>
-          <a:noFill/>
-        </p:spPr>
-        <p:txBody>
-          <a:bodyPr wrap="none">
-            <a:spAutoFit/>
-          </a:bodyPr>
-          <a:lstStyle/>
-          <a:p>
-            <a:r>
-              <a:rPr sz="3800" b="1">
-                <a:solidFill>
-                  <a:srgbClr val="0D2A3E"/>
-                </a:solidFill>
-              </a:rPr>
-              <a:t>Thank You</a:t>
-            </a:r>
-          </a:p>
-        </p:txBody>
-      </p:sp>
-      <p:sp>
-        <p:nvSpPr>
-          <p:cNvPr id="3" name="TextBox 2"/>
-          <p:cNvSpPr txBox="1"/>
-          <p:nvPr/>
-        </p:nvSpPr>
-        <p:spPr>
-          <a:xfrm>
-            <a:off x="822960" y="2560320"/>
-            <a:ext cx="10972800" cy="4389120"/>
-          </a:xfrm>
-          <a:prstGeom prst="rect">
-            <a:avLst/>
-          </a:prstGeom>
-          <a:noFill/>
-        </p:spPr>
-        <p:txBody>
-          <a:bodyPr wrap="none">
-            <a:spAutoFit/>
-          </a:bodyPr>
-          <a:lstStyle/>
-          <a:p>
-            <a:pPr>
-              <a:spcAft>
-                <a:spcPts val="1200"/>
-              </a:spcAft>
-              <a:defRPr sz="2800">
-                <a:solidFill>
-                  <a:srgbClr val="2D2D2D"/>
-                </a:solidFill>
-              </a:defRPr>
-            </a:pPr>
-            <a:r>
-              <a:t>Questions and feedback</a:t>
-            </a:r>
-          </a:p>
-          <a:p>
-            <a:pPr>
-              <a:spcAft>
-                <a:spcPts val="1200"/>
-              </a:spcAft>
-              <a:defRPr sz="2800">
-                <a:solidFill>
-                  <a:srgbClr val="2D2D2D"/>
-                </a:solidFill>
-              </a:defRPr>
-            </a:pPr>
-            <a:r>
-              <a:t>Project repo includes reproducible scripts and artifact evidence.</a:t>
-            </a:r>
-          </a:p>
-        </p:txBody>
-      </p:sp>
-      <p:sp>
-        <p:nvSpPr>
-          <p:cNvPr id="4" name="Rectangle 3"/>
-          <p:cNvSpPr/>
-          <p:nvPr/>
-        </p:nvSpPr>
-        <p:spPr>
-          <a:xfrm>
-            <a:off x="548640" y="6263640"/>
-            <a:ext cx="11064240" cy="18288"/>
-          </a:xfrm>
-          <a:prstGeom prst="rect">
-            <a:avLst/>
-          </a:prstGeom>
-          <a:solidFill>
-            <a:srgbClr val="1A86D6"/>
-          </a:solidFill>
-          <a:ln>
-            <a:noFill/>
-          </a:ln>
-        </p:spPr>
-        <p:style>
-          <a:lnRef idx="1">
-            <a:schemeClr val="accent1"/>
-          </a:lnRef>
-          <a:fillRef idx="3">
-            <a:schemeClr val="accent1"/>
-          </a:fillRef>
-          <a:effectRef idx="2">
-            <a:schemeClr val="accent1"/>
-          </a:effectRef>
-          <a:fontRef idx="minor">
-            <a:schemeClr val="lt1"/>
-          </a:fontRef>
-        </p:style>
-        <p:txBody>
-          <a:bodyPr rtlCol="0" anchor="ctr"/>
-          <a:lstStyle/>
-          <a:p>
-            <a:pPr algn="ctr"/>
-          </a:p>
-        </p:txBody>
-      </p:sp>
-      <p:sp>
-        <p:nvSpPr>
-          <p:cNvPr id="5" name="TextBox 4"/>
-          <p:cNvSpPr txBox="1"/>
-          <p:nvPr/>
-        </p:nvSpPr>
-        <p:spPr>
-          <a:xfrm>
-            <a:off x="640080" y="6355080"/>
-            <a:ext cx="7772400" cy="365760"/>
-          </a:xfrm>
-          <a:prstGeom prst="rect">
-            <a:avLst/>
-          </a:prstGeom>
-          <a:noFill/>
-        </p:spPr>
-        <p:txBody>
-          <a:bodyPr wrap="none">
-            <a:spAutoFit/>
-          </a:bodyPr>
-          <a:lstStyle/>
-          <a:p>
-            <a:pPr>
-              <a:defRPr sz="1200">
-                <a:solidFill>
-                  <a:srgbClr val="5A5A5A"/>
-                </a:solidFill>
-              </a:defRPr>
-            </a:pPr>
-            <a:r>
-              <a:t>Myriad | Privacy-first mindful habit tracking</a:t>
-            </a:r>
-          </a:p>
-        </p:txBody>
-      </p:sp>
-      <p:sp>
-        <p:nvSpPr>
-          <p:cNvPr id="6" name="TextBox 5"/>
-          <p:cNvSpPr txBox="1"/>
-          <p:nvPr/>
-        </p:nvSpPr>
-        <p:spPr>
-          <a:xfrm>
-            <a:off x="8869680" y="6355080"/>
-            <a:ext cx="2651760" cy="365760"/>
-          </a:xfrm>
-          <a:prstGeom prst="rect">
-            <a:avLst/>
-          </a:prstGeom>
-          <a:noFill/>
-        </p:spPr>
-        <p:txBody>
-          <a:bodyPr wrap="none">
-            <a:spAutoFit/>
-          </a:bodyPr>
-          <a:lstStyle/>
-          <a:p>
-            <a:pPr algn="ctr">
-              <a:defRPr sz="1200">
-                <a:solidFill>
-                  <a:srgbClr val="5A5A5A"/>
-                </a:solidFill>
-              </a:defRPr>
-            </a:pPr>
-            <a:r>
-              <a:t>15 Apr 2026</a:t>
+              <a:t>16 Apr 2026</a:t>
             </a:r>
           </a:p>
         </p:txBody>
@@ -4117,8 +3422,8 @@
         </p:nvSpPr>
         <p:spPr>
           <a:xfrm>
-            <a:off x="640080" y="365760"/>
-            <a:ext cx="10789920" cy="1097280"/>
+            <a:off x="502920" y="320040"/>
+            <a:ext cx="11155680" cy="731520"/>
           </a:xfrm>
           <a:prstGeom prst="rect">
             <a:avLst/>
@@ -4132,12 +3437,12 @@
           <a:lstStyle/>
           <a:p>
             <a:r>
-              <a:rPr sz="3800" b="1">
+              <a:rPr sz="3400" b="1">
                 <a:solidFill>
                   <a:srgbClr val="0D2A3E"/>
                 </a:solidFill>
               </a:rPr>
-              <a:t>Problem and Aim</a:t>
+              <a:t>Problem, Aim, and Architecture</a:t>
             </a:r>
           </a:p>
         </p:txBody>
@@ -4150,8 +3455,115 @@
         </p:nvSpPr>
         <p:spPr>
           <a:xfrm>
-            <a:off x="822960" y="1645920"/>
-            <a:ext cx="10972800" cy="4389120"/>
+            <a:off x="685800" y="1234440"/>
+            <a:ext cx="5303520" cy="5303520"/>
+          </a:xfrm>
+          <a:prstGeom prst="rect">
+            <a:avLst/>
+          </a:prstGeom>
+          <a:noFill/>
+        </p:spPr>
+        <p:txBody>
+          <a:bodyPr wrap="square">
+            <a:spAutoFit/>
+          </a:bodyPr>
+          <a:lstStyle/>
+          <a:p>
+            <a:pPr>
+              <a:spcAft>
+                <a:spcPts val="1000"/>
+              </a:spcAft>
+              <a:defRPr sz="1900">
+                <a:solidFill>
+                  <a:srgbClr val="2D2D2D"/>
+                </a:solidFill>
+              </a:defRPr>
+            </a:pPr>
+            <a:r>
+              <a:t>Usage drifts without timely feedback or practical intervention.</a:t>
+            </a:r>
+          </a:p>
+          <a:p>
+            <a:pPr>
+              <a:spcAft>
+                <a:spcPts val="1000"/>
+              </a:spcAft>
+              <a:defRPr sz="1900">
+                <a:solidFill>
+                  <a:srgbClr val="2D2D2D"/>
+                </a:solidFill>
+              </a:defRPr>
+            </a:pPr>
+            <a:r>
+              <a:t>Myriad turns local event history into behavior-change plans.</a:t>
+            </a:r>
+          </a:p>
+          <a:p>
+            <a:pPr>
+              <a:spcAft>
+                <a:spcPts val="1000"/>
+              </a:spcAft>
+              <a:defRPr sz="1900">
+                <a:solidFill>
+                  <a:srgbClr val="2D2D2D"/>
+                </a:solidFill>
+              </a:defRPr>
+            </a:pPr>
+            <a:r>
+              <a:t>Core stack: Electron, Express, SQLite, and browser/chat import connectors.</a:t>
+            </a:r>
+          </a:p>
+          <a:p>
+            <a:pPr>
+              <a:spcAft>
+                <a:spcPts val="1000"/>
+              </a:spcAft>
+              <a:defRPr sz="1900">
+                <a:solidFill>
+                  <a:srgbClr val="2D2D2D"/>
+                </a:solidFill>
+              </a:defRPr>
+            </a:pPr>
+            <a:r>
+              <a:t>No external analytics backend is required for the MVP.</a:t>
+            </a:r>
+          </a:p>
+        </p:txBody>
+      </p:sp>
+      <p:pic>
+        <p:nvPicPr>
+          <p:cNvPr id="4" name="Picture 3" descr="myriad_stats.png"/>
+          <p:cNvPicPr>
+            <a:picLocks noChangeAspect="1"/>
+          </p:cNvPicPr>
+          <p:nvPr/>
+        </p:nvPicPr>
+        <p:blipFill>
+          <a:blip r:embed="rId2"/>
+          <a:stretch>
+            <a:fillRect/>
+          </a:stretch>
+        </p:blipFill>
+        <p:spPr>
+          <a:xfrm>
+            <a:off x="5989320" y="1143000"/>
+            <a:ext cx="5394960" cy="6998462"/>
+          </a:xfrm>
+          <a:prstGeom prst="rect">
+            <a:avLst/>
+          </a:prstGeom>
+        </p:spPr>
+      </p:pic>
+      <p:sp>
+        <p:nvSpPr>
+          <p:cNvPr id="5" name="TextBox 4"/>
+          <p:cNvSpPr txBox="1"/>
+          <p:nvPr/>
+        </p:nvSpPr>
+        <p:spPr>
+          <a:xfrm>
+            <a:off x="5989320" y="5440680"/>
+            <a:ext cx="5394960" cy="320040"/>
           </a:xfrm>
           <a:prstGeom prst="rect">
             <a:avLst/>
@@ -4164,62 +3576,29 @@
           </a:bodyPr>
           <a:lstStyle/>
           <a:p>
-            <a:pPr>
-              <a:spcAft>
-                <a:spcPts val="1200"/>
-              </a:spcAft>
-              <a:defRPr sz="2200">
-                <a:solidFill>
-                  <a:srgbClr val="2D2D2D"/>
+            <a:pPr algn="l">
+              <a:defRPr sz="1100">
+                <a:solidFill>
+                  <a:srgbClr val="5C5C5C"/>
                 </a:solidFill>
               </a:defRPr>
             </a:pPr>
             <a:r>
-              <a:t>Digital habits can drift without timely feedback and practical interventions.</a:t>
-            </a:r>
-          </a:p>
-          <a:p>
-            <a:pPr>
-              <a:spcAft>
-                <a:spcPts val="1200"/>
-              </a:spcAft>
-              <a:defRPr sz="2200">
-                <a:solidFill>
-                  <a:srgbClr val="2D2D2D"/>
-                </a:solidFill>
-              </a:defRPr>
-            </a:pPr>
-            <a:r>
-              <a:t>Users need actionable insights without sacrificing data privacy.</a:t>
-            </a:r>
-          </a:p>
-          <a:p>
-            <a:pPr>
-              <a:spcAft>
-                <a:spcPts val="1200"/>
-              </a:spcAft>
-              <a:defRPr sz="2200">
-                <a:solidFill>
-                  <a:srgbClr val="2D2D2D"/>
-                </a:solidFill>
-              </a:defRPr>
-            </a:pPr>
-            <a:r>
-              <a:t>Goal: deliver a local-first system that turns event history into adaptive intervention plans.</a:t>
-            </a:r>
-          </a:p>
-        </p:txBody>
-      </p:sp>
-      <p:sp>
-        <p:nvSpPr>
-          <p:cNvPr id="4" name="Rectangle 3"/>
+              <a:t>Stats / intervention view</a:t>
+            </a:r>
+          </a:p>
+        </p:txBody>
+      </p:sp>
+      <p:sp>
+        <p:nvSpPr>
+          <p:cNvPr id="6" name="Rectangle 5"/>
           <p:cNvSpPr/>
           <p:nvPr/>
         </p:nvSpPr>
         <p:spPr>
           <a:xfrm>
-            <a:off x="548640" y="6263640"/>
-            <a:ext cx="11064240" cy="18288"/>
+            <a:off x="502920" y="6309360"/>
+            <a:ext cx="11201400" cy="27432"/>
           </a:xfrm>
           <a:prstGeom prst="rect">
             <a:avLst/>
@@ -4255,14 +3634,14 @@
       </p:sp>
       <p:sp>
         <p:nvSpPr>
-          <p:cNvPr id="5" name="TextBox 4"/>
+          <p:cNvPr id="7" name="TextBox 6"/>
           <p:cNvSpPr txBox="1"/>
           <p:nvPr/>
         </p:nvSpPr>
         <p:spPr>
           <a:xfrm>
-            <a:off x="640080" y="6355080"/>
-            <a:ext cx="7772400" cy="365760"/>
+            <a:off x="502920" y="6400800"/>
+            <a:ext cx="6400800" cy="228600"/>
           </a:xfrm>
           <a:prstGeom prst="rect">
             <a:avLst/>
@@ -4276,28 +3655,28 @@
           <a:lstStyle/>
           <a:p>
             <a:pPr>
-              <a:defRPr sz="1200">
-                <a:solidFill>
-                  <a:srgbClr val="5A5A5A"/>
+              <a:defRPr sz="1000">
+                <a:solidFill>
+                  <a:srgbClr val="5C5C5C"/>
                 </a:solidFill>
               </a:defRPr>
             </a:pPr>
             <a:r>
-              <a:t>Myriad | Privacy-first mindful habit tracking</a:t>
-            </a:r>
-          </a:p>
-        </p:txBody>
-      </p:sp>
-      <p:sp>
-        <p:nvSpPr>
-          <p:cNvPr id="6" name="TextBox 5"/>
+              <a:t>Myriad</a:t>
+            </a:r>
+          </a:p>
+        </p:txBody>
+      </p:sp>
+      <p:sp>
+        <p:nvSpPr>
+          <p:cNvPr id="8" name="TextBox 7"/>
           <p:cNvSpPr txBox="1"/>
           <p:nvPr/>
         </p:nvSpPr>
         <p:spPr>
           <a:xfrm>
-            <a:off x="8869680" y="6355080"/>
-            <a:ext cx="2651760" cy="365760"/>
+            <a:off x="9966960" y="6400800"/>
+            <a:ext cx="1737360" cy="228600"/>
           </a:xfrm>
           <a:prstGeom prst="rect">
             <a:avLst/>
@@ -4311,14 +3690,14 @@
           <a:lstStyle/>
           <a:p>
             <a:pPr algn="ctr">
-              <a:defRPr sz="1200">
-                <a:solidFill>
-                  <a:srgbClr val="5A5A5A"/>
+              <a:defRPr sz="1000">
+                <a:solidFill>
+                  <a:srgbClr val="5C5C5C"/>
                 </a:solidFill>
               </a:defRPr>
             </a:pPr>
             <a:r>
-              <a:t>15 Apr 2026</a:t>
+              <a:t>16 Apr 2026</a:t>
             </a:r>
           </a:p>
         </p:txBody>
@@ -4357,8 +3736,8 @@
         </p:nvSpPr>
         <p:spPr>
           <a:xfrm>
-            <a:off x="640080" y="365760"/>
-            <a:ext cx="10789920" cy="1097280"/>
+            <a:off x="502920" y="320040"/>
+            <a:ext cx="11155680" cy="731520"/>
           </a:xfrm>
           <a:prstGeom prst="rect">
             <a:avLst/>
@@ -4372,26 +3751,50 @@
           <a:lstStyle/>
           <a:p>
             <a:r>
-              <a:rPr sz="3800" b="1">
+              <a:rPr sz="3400" b="1">
                 <a:solidFill>
                   <a:srgbClr val="0D2A3E"/>
                 </a:solidFill>
               </a:rPr>
-              <a:t>Implemented Architecture</a:t>
-            </a:r>
-          </a:p>
-        </p:txBody>
-      </p:sp>
-      <p:sp>
-        <p:nvSpPr>
-          <p:cNvPr id="3" name="TextBox 2"/>
+              <a:t>App Screenshots</a:t>
+            </a:r>
+          </a:p>
+        </p:txBody>
+      </p:sp>
+      <p:pic>
+        <p:nvPicPr>
+          <p:cNvPr id="3" name="Picture 2" descr="myriad_home.png"/>
+          <p:cNvPicPr>
+            <a:picLocks noChangeAspect="1"/>
+          </p:cNvPicPr>
+          <p:nvPr/>
+        </p:nvPicPr>
+        <p:blipFill>
+          <a:blip r:embed="rId2"/>
+          <a:stretch>
+            <a:fillRect/>
+          </a:stretch>
+        </p:blipFill>
+        <p:spPr>
+          <a:xfrm>
+            <a:off x="594360" y="1234440"/>
+            <a:ext cx="3657600" cy="2286000"/>
+          </a:xfrm>
+          <a:prstGeom prst="rect">
+            <a:avLst/>
+          </a:prstGeom>
+        </p:spPr>
+      </p:pic>
+      <p:sp>
+        <p:nvSpPr>
+          <p:cNvPr id="4" name="TextBox 3"/>
           <p:cNvSpPr txBox="1"/>
           <p:nvPr/>
         </p:nvSpPr>
         <p:spPr>
           <a:xfrm>
-            <a:off x="822960" y="1645920"/>
-            <a:ext cx="10972800" cy="4389120"/>
+            <a:off x="594360" y="3108960"/>
+            <a:ext cx="3657600" cy="320040"/>
           </a:xfrm>
           <a:prstGeom prst="rect">
             <a:avLst/>
@@ -4404,77 +3807,265 @@
           </a:bodyPr>
           <a:lstStyle/>
           <a:p>
-            <a:pPr>
-              <a:spcAft>
-                <a:spcPts val="1200"/>
-              </a:spcAft>
-              <a:defRPr sz="2200">
-                <a:solidFill>
-                  <a:srgbClr val="2D2D2D"/>
+            <a:pPr algn="l">
+              <a:defRPr sz="1100">
+                <a:solidFill>
+                  <a:srgbClr val="5C5C5C"/>
                 </a:solidFill>
               </a:defRPr>
             </a:pPr>
             <a:r>
-              <a:t>Electron desktop app + local Express API + SQLite (better-sqlite3).</a:t>
-            </a:r>
-          </a:p>
-          <a:p>
-            <a:pPr>
-              <a:spcAft>
-                <a:spcPts val="1200"/>
-              </a:spcAft>
-              <a:defRPr sz="2200">
-                <a:solidFill>
-                  <a:srgbClr val="2D2D2D"/>
+              <a:t>Home and import flow</a:t>
+            </a:r>
+          </a:p>
+        </p:txBody>
+      </p:sp>
+      <p:pic>
+        <p:nvPicPr>
+          <p:cNvPr id="5" name="Picture 4" descr="myriad_stats.png"/>
+          <p:cNvPicPr>
+            <a:picLocks noChangeAspect="1"/>
+          </p:cNvPicPr>
+          <p:nvPr/>
+        </p:nvPicPr>
+        <p:blipFill>
+          <a:blip r:embed="rId3"/>
+          <a:stretch>
+            <a:fillRect/>
+          </a:stretch>
+        </p:blipFill>
+        <p:spPr>
+          <a:xfrm>
+            <a:off x="4251960" y="1234440"/>
+            <a:ext cx="3657600" cy="4744720"/>
+          </a:xfrm>
+          <a:prstGeom prst="rect">
+            <a:avLst/>
+          </a:prstGeom>
+        </p:spPr>
+      </p:pic>
+      <p:sp>
+        <p:nvSpPr>
+          <p:cNvPr id="6" name="TextBox 5"/>
+          <p:cNvSpPr txBox="1"/>
+          <p:nvPr/>
+        </p:nvSpPr>
+        <p:spPr>
+          <a:xfrm>
+            <a:off x="4251960" y="3108960"/>
+            <a:ext cx="3657600" cy="320040"/>
+          </a:xfrm>
+          <a:prstGeom prst="rect">
+            <a:avLst/>
+          </a:prstGeom>
+          <a:noFill/>
+        </p:spPr>
+        <p:txBody>
+          <a:bodyPr wrap="none">
+            <a:spAutoFit/>
+          </a:bodyPr>
+          <a:lstStyle/>
+          <a:p>
+            <a:pPr algn="l">
+              <a:defRPr sz="1100">
+                <a:solidFill>
+                  <a:srgbClr val="5C5C5C"/>
                 </a:solidFill>
               </a:defRPr>
             </a:pPr>
             <a:r>
-              <a:t>Connector imports: browser history, WhatsApp, Telegram.</a:t>
-            </a:r>
-          </a:p>
-          <a:p>
-            <a:pPr>
-              <a:spcAft>
-                <a:spcPts val="1200"/>
-              </a:spcAft>
-              <a:defRPr sz="2200">
-                <a:solidFill>
-                  <a:srgbClr val="2D2D2D"/>
+              <a:t>Stats and interventions</a:t>
+            </a:r>
+          </a:p>
+        </p:txBody>
+      </p:sp>
+      <p:pic>
+        <p:nvPicPr>
+          <p:cNvPr id="7" name="Picture 6" descr="poc_category_usage.png"/>
+          <p:cNvPicPr>
+            <a:picLocks noChangeAspect="1"/>
+          </p:cNvPicPr>
+          <p:nvPr/>
+        </p:nvPicPr>
+        <p:blipFill>
+          <a:blip r:embed="rId4"/>
+          <a:stretch>
+            <a:fillRect/>
+          </a:stretch>
+        </p:blipFill>
+        <p:spPr>
+          <a:xfrm>
+            <a:off x="7909560" y="1234440"/>
+            <a:ext cx="3657600" cy="1828800"/>
+          </a:xfrm>
+          <a:prstGeom prst="rect">
+            <a:avLst/>
+          </a:prstGeom>
+        </p:spPr>
+      </p:pic>
+      <p:sp>
+        <p:nvSpPr>
+          <p:cNvPr id="8" name="TextBox 7"/>
+          <p:cNvSpPr txBox="1"/>
+          <p:nvPr/>
+        </p:nvSpPr>
+        <p:spPr>
+          <a:xfrm>
+            <a:off x="7909560" y="3108960"/>
+            <a:ext cx="3657600" cy="320040"/>
+          </a:xfrm>
+          <a:prstGeom prst="rect">
+            <a:avLst/>
+          </a:prstGeom>
+          <a:noFill/>
+        </p:spPr>
+        <p:txBody>
+          <a:bodyPr wrap="none">
+            <a:spAutoFit/>
+          </a:bodyPr>
+          <a:lstStyle/>
+          <a:p>
+            <a:pPr algn="l">
+              <a:defRPr sz="1100">
+                <a:solidFill>
+                  <a:srgbClr val="5C5C5C"/>
                 </a:solidFill>
               </a:defRPr>
             </a:pPr>
             <a:r>
-              <a:t>Dashboard analytics with Chart.js and intervention planning endpoints.</a:t>
-            </a:r>
-          </a:p>
-          <a:p>
-            <a:pPr>
-              <a:spcAft>
-                <a:spcPts val="1200"/>
-              </a:spcAft>
-              <a:defRPr sz="2200">
-                <a:solidFill>
-                  <a:srgbClr val="2D2D2D"/>
+              <a:t>Category usage chart</a:t>
+            </a:r>
+          </a:p>
+        </p:txBody>
+      </p:sp>
+      <p:pic>
+        <p:nvPicPr>
+          <p:cNvPr id="9" name="Picture 8" descr="poc_sentiment_trend.png"/>
+          <p:cNvPicPr>
+            <a:picLocks noChangeAspect="1"/>
+          </p:cNvPicPr>
+          <p:nvPr/>
+        </p:nvPicPr>
+        <p:blipFill>
+          <a:blip r:embed="rId5"/>
+          <a:stretch>
+            <a:fillRect/>
+          </a:stretch>
+        </p:blipFill>
+        <p:spPr>
+          <a:xfrm>
+            <a:off x="1874519" y="3703320"/>
+            <a:ext cx="3657600" cy="1828800"/>
+          </a:xfrm>
+          <a:prstGeom prst="rect">
+            <a:avLst/>
+          </a:prstGeom>
+        </p:spPr>
+      </p:pic>
+      <p:sp>
+        <p:nvSpPr>
+          <p:cNvPr id="10" name="TextBox 9"/>
+          <p:cNvSpPr txBox="1"/>
+          <p:nvPr/>
+        </p:nvSpPr>
+        <p:spPr>
+          <a:xfrm>
+            <a:off x="1874519" y="5577840"/>
+            <a:ext cx="3657600" cy="320040"/>
+          </a:xfrm>
+          <a:prstGeom prst="rect">
+            <a:avLst/>
+          </a:prstGeom>
+          <a:noFill/>
+        </p:spPr>
+        <p:txBody>
+          <a:bodyPr wrap="none">
+            <a:spAutoFit/>
+          </a:bodyPr>
+          <a:lstStyle/>
+          <a:p>
+            <a:pPr algn="l">
+              <a:defRPr sz="1100">
+                <a:solidFill>
+                  <a:srgbClr val="5C5C5C"/>
                 </a:solidFill>
               </a:defRPr>
             </a:pPr>
             <a:r>
-              <a:t>No cloud dependency required for core functionality.</a:t>
-            </a:r>
-          </a:p>
-        </p:txBody>
-      </p:sp>
-      <p:sp>
-        <p:nvSpPr>
-          <p:cNvPr id="4" name="Rectangle 3"/>
+              <a:t>Sentiment trend</a:t>
+            </a:r>
+          </a:p>
+        </p:txBody>
+      </p:sp>
+      <p:pic>
+        <p:nvPicPr>
+          <p:cNvPr id="11" name="Picture 10" descr="poc_test_outcomes.png"/>
+          <p:cNvPicPr>
+            <a:picLocks noChangeAspect="1"/>
+          </p:cNvPicPr>
+          <p:nvPr/>
+        </p:nvPicPr>
+        <p:blipFill>
+          <a:blip r:embed="rId6"/>
+          <a:stretch>
+            <a:fillRect/>
+          </a:stretch>
+        </p:blipFill>
+        <p:spPr>
+          <a:xfrm>
+            <a:off x="5532120" y="3703320"/>
+            <a:ext cx="3657600" cy="2286000"/>
+          </a:xfrm>
+          <a:prstGeom prst="rect">
+            <a:avLst/>
+          </a:prstGeom>
+        </p:spPr>
+      </p:pic>
+      <p:sp>
+        <p:nvSpPr>
+          <p:cNvPr id="12" name="TextBox 11"/>
+          <p:cNvSpPr txBox="1"/>
+          <p:nvPr/>
+        </p:nvSpPr>
+        <p:spPr>
+          <a:xfrm>
+            <a:off x="5532120" y="5577840"/>
+            <a:ext cx="3657600" cy="320040"/>
+          </a:xfrm>
+          <a:prstGeom prst="rect">
+            <a:avLst/>
+          </a:prstGeom>
+          <a:noFill/>
+        </p:spPr>
+        <p:txBody>
+          <a:bodyPr wrap="none">
+            <a:spAutoFit/>
+          </a:bodyPr>
+          <a:lstStyle/>
+          <a:p>
+            <a:pPr algn="l">
+              <a:defRPr sz="1100">
+                <a:solidFill>
+                  <a:srgbClr val="5C5C5C"/>
+                </a:solidFill>
+              </a:defRPr>
+            </a:pPr>
+            <a:r>
+              <a:t>Validation outcomes</a:t>
+            </a:r>
+          </a:p>
+        </p:txBody>
+      </p:sp>
+      <p:sp>
+        <p:nvSpPr>
+          <p:cNvPr id="13" name="Rectangle 12"/>
           <p:cNvSpPr/>
           <p:nvPr/>
         </p:nvSpPr>
         <p:spPr>
           <a:xfrm>
-            <a:off x="548640" y="6263640"/>
-            <a:ext cx="11064240" cy="18288"/>
+            <a:off x="502920" y="6309360"/>
+            <a:ext cx="11201400" cy="27432"/>
           </a:xfrm>
           <a:prstGeom prst="rect">
             <a:avLst/>
@@ -4510,14 +4101,14 @@
       </p:sp>
       <p:sp>
         <p:nvSpPr>
-          <p:cNvPr id="5" name="TextBox 4"/>
+          <p:cNvPr id="14" name="TextBox 13"/>
           <p:cNvSpPr txBox="1"/>
           <p:nvPr/>
         </p:nvSpPr>
         <p:spPr>
           <a:xfrm>
-            <a:off x="640080" y="6355080"/>
-            <a:ext cx="7772400" cy="365760"/>
+            <a:off x="502920" y="6400800"/>
+            <a:ext cx="6400800" cy="228600"/>
           </a:xfrm>
           <a:prstGeom prst="rect">
             <a:avLst/>
@@ -4531,28 +4122,28 @@
           <a:lstStyle/>
           <a:p>
             <a:pPr>
-              <a:defRPr sz="1200">
-                <a:solidFill>
-                  <a:srgbClr val="5A5A5A"/>
+              <a:defRPr sz="1000">
+                <a:solidFill>
+                  <a:srgbClr val="5C5C5C"/>
                 </a:solidFill>
               </a:defRPr>
             </a:pPr>
             <a:r>
-              <a:t>Myriad | Privacy-first mindful habit tracking</a:t>
-            </a:r>
-          </a:p>
-        </p:txBody>
-      </p:sp>
-      <p:sp>
-        <p:nvSpPr>
-          <p:cNvPr id="6" name="TextBox 5"/>
+              <a:t>Myriad</a:t>
+            </a:r>
+          </a:p>
+        </p:txBody>
+      </p:sp>
+      <p:sp>
+        <p:nvSpPr>
+          <p:cNvPr id="15" name="TextBox 14"/>
           <p:cNvSpPr txBox="1"/>
           <p:nvPr/>
         </p:nvSpPr>
         <p:spPr>
           <a:xfrm>
-            <a:off x="8869680" y="6355080"/>
-            <a:ext cx="2651760" cy="365760"/>
+            <a:off x="9966960" y="6400800"/>
+            <a:ext cx="1737360" cy="228600"/>
           </a:xfrm>
           <a:prstGeom prst="rect">
             <a:avLst/>
@@ -4566,14 +4157,14 @@
           <a:lstStyle/>
           <a:p>
             <a:pPr algn="ctr">
-              <a:defRPr sz="1200">
-                <a:solidFill>
-                  <a:srgbClr val="5A5A5A"/>
+              <a:defRPr sz="1000">
+                <a:solidFill>
+                  <a:srgbClr val="5C5C5C"/>
                 </a:solidFill>
               </a:defRPr>
             </a:pPr>
             <a:r>
-              <a:t>15 Apr 2026</a:t>
+              <a:t>16 Apr 2026</a:t>
             </a:r>
           </a:p>
         </p:txBody>
@@ -4592,7 +4183,7 @@
     <p:bg>
       <p:bgPr>
         <a:solidFill>
-          <a:srgbClr val="FFFAF5"/>
+          <a:srgbClr val="FFF8FA"/>
         </a:solidFill>
         <a:effectLst/>
       </p:bgPr>
@@ -4612,8 +4203,8 @@
         </p:nvSpPr>
         <p:spPr>
           <a:xfrm>
-            <a:off x="640080" y="365760"/>
-            <a:ext cx="10789920" cy="1097280"/>
+            <a:off x="502920" y="320040"/>
+            <a:ext cx="11155680" cy="731520"/>
           </a:xfrm>
           <a:prstGeom prst="rect">
             <a:avLst/>
@@ -4627,12 +4218,12 @@
           <a:lstStyle/>
           <a:p>
             <a:r>
-              <a:rPr sz="3800" b="1">
+              <a:rPr sz="3400" b="1">
                 <a:solidFill>
                   <a:srgbClr val="0D2A3E"/>
                 </a:solidFill>
               </a:rPr>
-              <a:t>Privacy and Security Controls</a:t>
+              <a:t>Adaptive Relapse Risk Scoring</a:t>
             </a:r>
           </a:p>
         </p:txBody>
@@ -4645,8 +4236,115 @@
         </p:nvSpPr>
         <p:spPr>
           <a:xfrm>
-            <a:off x="822960" y="1645920"/>
-            <a:ext cx="10972800" cy="4389120"/>
+            <a:off x="685800" y="1234440"/>
+            <a:ext cx="5394960" cy="5303520"/>
+          </a:xfrm>
+          <a:prstGeom prst="rect">
+            <a:avLst/>
+          </a:prstGeom>
+          <a:noFill/>
+        </p:spPr>
+        <p:txBody>
+          <a:bodyPr wrap="square">
+            <a:spAutoFit/>
+          </a:bodyPr>
+          <a:lstStyle/>
+          <a:p>
+            <a:pPr>
+              <a:spcAft>
+                <a:spcPts val="1000"/>
+              </a:spcAft>
+              <a:defRPr sz="1900">
+                <a:solidFill>
+                  <a:srgbClr val="2D2D2D"/>
+                </a:solidFill>
+              </a:defRPr>
+            </a:pPr>
+            <a:r>
+              <a:t>Risk combines trend, device usage, and time-of-day patterns.</a:t>
+            </a:r>
+          </a:p>
+          <a:p>
+            <a:pPr>
+              <a:spcAft>
+                <a:spcPts val="1000"/>
+              </a:spcAft>
+              <a:defRPr sz="1900">
+                <a:solidFill>
+                  <a:srgbClr val="2D2D2D"/>
+                </a:solidFill>
+              </a:defRPr>
+            </a:pPr>
+            <a:r>
+              <a:t>The app classifies each goal as low, moderate, high, or critical risk.</a:t>
+            </a:r>
+          </a:p>
+          <a:p>
+            <a:pPr>
+              <a:spcAft>
+                <a:spcPts val="1000"/>
+              </a:spcAft>
+              <a:defRPr sz="1900">
+                <a:solidFill>
+                  <a:srgbClr val="2D2D2D"/>
+                </a:solidFill>
+              </a:defRPr>
+            </a:pPr>
+            <a:r>
+              <a:t>Intervention prompts intensify automatically as risk rises.</a:t>
+            </a:r>
+          </a:p>
+          <a:p>
+            <a:pPr>
+              <a:spcAft>
+                <a:spcPts val="1000"/>
+              </a:spcAft>
+              <a:defRPr sz="1900">
+                <a:solidFill>
+                  <a:srgbClr val="2D2D2D"/>
+                </a:solidFill>
+              </a:defRPr>
+            </a:pPr>
+            <a:r>
+              <a:t>The plan endpoint exposes detailed risk diagnostics for transparency.</a:t>
+            </a:r>
+          </a:p>
+        </p:txBody>
+      </p:sp>
+      <p:pic>
+        <p:nvPicPr>
+          <p:cNvPr id="4" name="Picture 3" descr="poc_category_usage.png"/>
+          <p:cNvPicPr>
+            <a:picLocks noChangeAspect="1"/>
+          </p:cNvPicPr>
+          <p:nvPr/>
+        </p:nvPicPr>
+        <p:blipFill>
+          <a:blip r:embed="rId2"/>
+          <a:stretch>
+            <a:fillRect/>
+          </a:stretch>
+        </p:blipFill>
+        <p:spPr>
+          <a:xfrm>
+            <a:off x="6080760" y="1143000"/>
+            <a:ext cx="5212080" cy="2606040"/>
+          </a:xfrm>
+          <a:prstGeom prst="rect">
+            <a:avLst/>
+          </a:prstGeom>
+        </p:spPr>
+      </p:pic>
+      <p:sp>
+        <p:nvSpPr>
+          <p:cNvPr id="5" name="TextBox 4"/>
+          <p:cNvSpPr txBox="1"/>
+          <p:nvPr/>
+        </p:nvSpPr>
+        <p:spPr>
+          <a:xfrm>
+            <a:off x="6080760" y="5394960"/>
+            <a:ext cx="5212080" cy="320040"/>
           </a:xfrm>
           <a:prstGeom prst="rect">
             <a:avLst/>
@@ -4659,77 +4357,29 @@
           </a:bodyPr>
           <a:lstStyle/>
           <a:p>
-            <a:pPr>
-              <a:spcAft>
-                <a:spcPts val="1200"/>
-              </a:spcAft>
-              <a:defRPr sz="2200">
-                <a:solidFill>
-                  <a:srgbClr val="2D2D2D"/>
+            <a:pPr algn="l">
+              <a:defRPr sz="1100">
+                <a:solidFill>
+                  <a:srgbClr val="5C5C5C"/>
                 </a:solidFill>
               </a:defRPr>
             </a:pPr>
             <a:r>
-              <a:t>Strict salt enforcement prevents insecure default anonymization.</a:t>
-            </a:r>
-          </a:p>
-          <a:p>
-            <a:pPr>
-              <a:spcAft>
-                <a:spcPts val="1200"/>
-              </a:spcAft>
-              <a:defRPr sz="2200">
-                <a:solidFill>
-                  <a:srgbClr val="2D2D2D"/>
-                </a:solidFill>
-              </a:defRPr>
-            </a:pPr>
-            <a:r>
-              <a:t>Admin-only global summary endpoint with explicit key requirement.</a:t>
-            </a:r>
-          </a:p>
-          <a:p>
-            <a:pPr>
-              <a:spcAft>
-                <a:spcPts val="1200"/>
-              </a:spcAft>
-              <a:defRPr sz="2200">
-                <a:solidFill>
-                  <a:srgbClr val="2D2D2D"/>
-                </a:solidFill>
-              </a:defRPr>
-            </a:pPr>
-            <a:r>
-              <a:t>Local processing by default reduces external data exposure.</a:t>
-            </a:r>
-          </a:p>
-          <a:p>
-            <a:pPr>
-              <a:spcAft>
-                <a:spcPts val="1200"/>
-              </a:spcAft>
-              <a:defRPr sz="2200">
-                <a:solidFill>
-                  <a:srgbClr val="2D2D2D"/>
-                </a:solidFill>
-              </a:defRPr>
-            </a:pPr>
-            <a:r>
-              <a:t>Health/status surfaces privacy warnings in the UI.</a:t>
-            </a:r>
-          </a:p>
-        </p:txBody>
-      </p:sp>
-      <p:sp>
-        <p:nvSpPr>
-          <p:cNvPr id="4" name="Rectangle 3"/>
+              <a:t>Pattern evidence used by the risk model</a:t>
+            </a:r>
+          </a:p>
+        </p:txBody>
+      </p:sp>
+      <p:sp>
+        <p:nvSpPr>
+          <p:cNvPr id="6" name="Rectangle 5"/>
           <p:cNvSpPr/>
           <p:nvPr/>
         </p:nvSpPr>
         <p:spPr>
           <a:xfrm>
-            <a:off x="548640" y="6263640"/>
-            <a:ext cx="11064240" cy="18288"/>
+            <a:off x="502920" y="6309360"/>
+            <a:ext cx="11201400" cy="27432"/>
           </a:xfrm>
           <a:prstGeom prst="rect">
             <a:avLst/>
@@ -4765,14 +4415,14 @@
       </p:sp>
       <p:sp>
         <p:nvSpPr>
-          <p:cNvPr id="5" name="TextBox 4"/>
+          <p:cNvPr id="7" name="TextBox 6"/>
           <p:cNvSpPr txBox="1"/>
           <p:nvPr/>
         </p:nvSpPr>
         <p:spPr>
           <a:xfrm>
-            <a:off x="640080" y="6355080"/>
-            <a:ext cx="7772400" cy="365760"/>
+            <a:off x="502920" y="6400800"/>
+            <a:ext cx="6400800" cy="228600"/>
           </a:xfrm>
           <a:prstGeom prst="rect">
             <a:avLst/>
@@ -4786,28 +4436,28 @@
           <a:lstStyle/>
           <a:p>
             <a:pPr>
-              <a:defRPr sz="1200">
-                <a:solidFill>
-                  <a:srgbClr val="5A5A5A"/>
+              <a:defRPr sz="1000">
+                <a:solidFill>
+                  <a:srgbClr val="5C5C5C"/>
                 </a:solidFill>
               </a:defRPr>
             </a:pPr>
             <a:r>
-              <a:t>Myriad | Privacy-first mindful habit tracking</a:t>
-            </a:r>
-          </a:p>
-        </p:txBody>
-      </p:sp>
-      <p:sp>
-        <p:nvSpPr>
-          <p:cNvPr id="6" name="TextBox 5"/>
+              <a:t>Myriad</a:t>
+            </a:r>
+          </a:p>
+        </p:txBody>
+      </p:sp>
+      <p:sp>
+        <p:nvSpPr>
+          <p:cNvPr id="8" name="TextBox 7"/>
           <p:cNvSpPr txBox="1"/>
           <p:nvPr/>
         </p:nvSpPr>
         <p:spPr>
           <a:xfrm>
-            <a:off x="8869680" y="6355080"/>
-            <a:ext cx="2651760" cy="365760"/>
+            <a:off x="9966960" y="6400800"/>
+            <a:ext cx="1737360" cy="228600"/>
           </a:xfrm>
           <a:prstGeom prst="rect">
             <a:avLst/>
@@ -4821,14 +4471,14 @@
           <a:lstStyle/>
           <a:p>
             <a:pPr algn="ctr">
-              <a:defRPr sz="1200">
-                <a:solidFill>
-                  <a:srgbClr val="5A5A5A"/>
+              <a:defRPr sz="1000">
+                <a:solidFill>
+                  <a:srgbClr val="5C5C5C"/>
                 </a:solidFill>
               </a:defRPr>
             </a:pPr>
             <a:r>
-              <a:t>15 Apr 2026</a:t>
+              <a:t>16 Apr 2026</a:t>
             </a:r>
           </a:p>
         </p:txBody>
@@ -4867,8 +4517,8 @@
         </p:nvSpPr>
         <p:spPr>
           <a:xfrm>
-            <a:off x="640080" y="365760"/>
-            <a:ext cx="10789920" cy="1097280"/>
+            <a:off x="502920" y="320040"/>
+            <a:ext cx="11155680" cy="731520"/>
           </a:xfrm>
           <a:prstGeom prst="rect">
             <a:avLst/>
@@ -4882,12 +4532,12 @@
           <a:lstStyle/>
           <a:p>
             <a:r>
-              <a:rPr sz="3800" b="1">
+              <a:rPr sz="3400" b="1">
                 <a:solidFill>
                   <a:srgbClr val="0D2A3E"/>
                 </a:solidFill>
               </a:rPr>
-              <a:t>Behavior-Change Engine</a:t>
+              <a:t>Video Walkthrough: Desktop Flow</a:t>
             </a:r>
           </a:p>
         </p:txBody>
@@ -4900,8 +4550,94 @@
         </p:nvSpPr>
         <p:spPr>
           <a:xfrm>
-            <a:off x="822960" y="1645920"/>
-            <a:ext cx="10972800" cy="4389120"/>
+            <a:off x="640080" y="1188720"/>
+            <a:ext cx="3749039" cy="5303520"/>
+          </a:xfrm>
+          <a:prstGeom prst="rect">
+            <a:avLst/>
+          </a:prstGeom>
+          <a:noFill/>
+        </p:spPr>
+        <p:txBody>
+          <a:bodyPr wrap="square">
+            <a:spAutoFit/>
+          </a:bodyPr>
+          <a:lstStyle/>
+          <a:p>
+            <a:pPr>
+              <a:spcAft>
+                <a:spcPts val="1000"/>
+              </a:spcAft>
+              <a:defRPr sz="2000">
+                <a:solidFill>
+                  <a:srgbClr val="2D2D2D"/>
+                </a:solidFill>
+              </a:defRPr>
+            </a:pPr>
+            <a:r>
+              <a:t>Embedded MP4 clip from the app demo.</a:t>
+            </a:r>
+          </a:p>
+          <a:p>
+            <a:pPr>
+              <a:spcAft>
+                <a:spcPts val="1000"/>
+              </a:spcAft>
+              <a:defRPr sz="2000">
+                <a:solidFill>
+                  <a:srgbClr val="2D2D2D"/>
+                </a:solidFill>
+              </a:defRPr>
+            </a:pPr>
+            <a:r>
+              <a:t>Covers setup, import, and visualisation flow.</a:t>
+            </a:r>
+          </a:p>
+        </p:txBody>
+      </p:sp>
+      <p:pic>
+        <p:nvPicPr>
+          <p:cNvPr id="4" name="myriad-setup-to-visualisation.mp4">
+            <a:hlinkClick r:id="" action="ppaction://media"/>
+          </p:cNvPr>
+          <p:cNvPicPr>
+            <a:picLocks noChangeAspect="1"/>
+          </p:cNvPicPr>
+          <p:nvPr>
+            <a:videoFile r:link="rId3"/>
+            <p:extLst>
+              <p:ext uri="{DAA4B4D4-6D71-4841-9C94-3DE7FCFB9230}">
+                <p14:media xmlns:p14="http://schemas.microsoft.com/office/powerpoint/2010/main" r:embed="rId2"/>
+              </p:ext>
+            </p:extLst>
+          </p:nvPr>
+        </p:nvPicPr>
+        <p:blipFill>
+          <a:blip r:embed="rId4"/>
+          <a:stretch>
+            <a:fillRect/>
+          </a:stretch>
+        </p:blipFill>
+        <p:spPr>
+          <a:xfrm>
+            <a:off x="4343400" y="1143000"/>
+            <a:ext cx="7223760" cy="4069080"/>
+          </a:xfrm>
+          <a:prstGeom prst="rect">
+            <a:avLst/>
+          </a:prstGeom>
+        </p:spPr>
+      </p:pic>
+      <p:sp>
+        <p:nvSpPr>
+          <p:cNvPr id="5" name="TextBox 4"/>
+          <p:cNvSpPr txBox="1"/>
+          <p:nvPr/>
+        </p:nvSpPr>
+        <p:spPr>
+          <a:xfrm>
+            <a:off x="4343400" y="5349240"/>
+            <a:ext cx="7223760" cy="320040"/>
           </a:xfrm>
           <a:prstGeom prst="rect">
             <a:avLst/>
@@ -4914,77 +4650,29 @@
           </a:bodyPr>
           <a:lstStyle/>
           <a:p>
-            <a:pPr>
-              <a:spcAft>
-                <a:spcPts val="1200"/>
-              </a:spcAft>
-              <a:defRPr sz="2200">
-                <a:solidFill>
-                  <a:srgbClr val="2D2D2D"/>
+            <a:pPr algn="l">
+              <a:defRPr sz="1100">
+                <a:solidFill>
+                  <a:srgbClr val="5C5C5C"/>
                 </a:solidFill>
               </a:defRPr>
             </a:pPr>
             <a:r>
-              <a:t>Users define measurable habit goals and review progress status.</a:t>
-            </a:r>
-          </a:p>
-          <a:p>
-            <a:pPr>
-              <a:spcAft>
-                <a:spcPts val="1200"/>
-              </a:spcAft>
-              <a:defRPr sz="2200">
-                <a:solidFill>
-                  <a:srgbClr val="2D2D2D"/>
-                </a:solidFill>
-              </a:defRPr>
-            </a:pPr>
-            <a:r>
-              <a:t>System classifies progress as on-track, at-risk, or off-track.</a:t>
-            </a:r>
-          </a:p>
-          <a:p>
-            <a:pPr>
-              <a:spcAft>
-                <a:spcPts val="1200"/>
-              </a:spcAft>
-              <a:defRPr sz="2200">
-                <a:solidFill>
-                  <a:srgbClr val="2D2D2D"/>
-                </a:solidFill>
-              </a:defRPr>
-            </a:pPr>
-            <a:r>
-              <a:t>Intervention plans are generated from recent behavior patterns.</a:t>
-            </a:r>
-          </a:p>
-          <a:p>
-            <a:pPr>
-              <a:spcAft>
-                <a:spcPts val="1200"/>
-              </a:spcAft>
-              <a:defRPr sz="2200">
-                <a:solidFill>
-                  <a:srgbClr val="2D2D2D"/>
-                </a:solidFill>
-              </a:defRPr>
-            </a:pPr>
-            <a:r>
-              <a:t>Plans include immediate actions, environment changes, and reflection prompts.</a:t>
-            </a:r>
-          </a:p>
-        </p:txBody>
-      </p:sp>
-      <p:sp>
-        <p:nvSpPr>
-          <p:cNvPr id="4" name="Rectangle 3"/>
+              <a:t>Embedded video clip</a:t>
+            </a:r>
+          </a:p>
+        </p:txBody>
+      </p:sp>
+      <p:sp>
+        <p:nvSpPr>
+          <p:cNvPr id="6" name="Rectangle 5"/>
           <p:cNvSpPr/>
           <p:nvPr/>
         </p:nvSpPr>
         <p:spPr>
           <a:xfrm>
-            <a:off x="548640" y="6263640"/>
-            <a:ext cx="11064240" cy="18288"/>
+            <a:off x="502920" y="6309360"/>
+            <a:ext cx="11201400" cy="27432"/>
           </a:xfrm>
           <a:prstGeom prst="rect">
             <a:avLst/>
@@ -5020,14 +4708,14 @@
       </p:sp>
       <p:sp>
         <p:nvSpPr>
-          <p:cNvPr id="5" name="TextBox 4"/>
+          <p:cNvPr id="7" name="TextBox 6"/>
           <p:cNvSpPr txBox="1"/>
           <p:nvPr/>
         </p:nvSpPr>
         <p:spPr>
           <a:xfrm>
-            <a:off x="640080" y="6355080"/>
-            <a:ext cx="7772400" cy="365760"/>
+            <a:off x="502920" y="6400800"/>
+            <a:ext cx="6400800" cy="228600"/>
           </a:xfrm>
           <a:prstGeom prst="rect">
             <a:avLst/>
@@ -5041,28 +4729,28 @@
           <a:lstStyle/>
           <a:p>
             <a:pPr>
-              <a:defRPr sz="1200">
-                <a:solidFill>
-                  <a:srgbClr val="5A5A5A"/>
+              <a:defRPr sz="1000">
+                <a:solidFill>
+                  <a:srgbClr val="5C5C5C"/>
                 </a:solidFill>
               </a:defRPr>
             </a:pPr>
             <a:r>
-              <a:t>Myriad | Privacy-first mindful habit tracking</a:t>
-            </a:r>
-          </a:p>
-        </p:txBody>
-      </p:sp>
-      <p:sp>
-        <p:nvSpPr>
-          <p:cNvPr id="6" name="TextBox 5"/>
+              <a:t>Myriad</a:t>
+            </a:r>
+          </a:p>
+        </p:txBody>
+      </p:sp>
+      <p:sp>
+        <p:nvSpPr>
+          <p:cNvPr id="8" name="TextBox 7"/>
           <p:cNvSpPr txBox="1"/>
           <p:nvPr/>
         </p:nvSpPr>
         <p:spPr>
           <a:xfrm>
-            <a:off x="8869680" y="6355080"/>
-            <a:ext cx="2651760" cy="365760"/>
+            <a:off x="9966960" y="6400800"/>
+            <a:ext cx="1737360" cy="228600"/>
           </a:xfrm>
           <a:prstGeom prst="rect">
             <a:avLst/>
@@ -5076,14 +4764,14 @@
           <a:lstStyle/>
           <a:p>
             <a:pPr algn="ctr">
-              <a:defRPr sz="1200">
-                <a:solidFill>
-                  <a:srgbClr val="5A5A5A"/>
+              <a:defRPr sz="1000">
+                <a:solidFill>
+                  <a:srgbClr val="5C5C5C"/>
                 </a:solidFill>
               </a:defRPr>
             </a:pPr>
             <a:r>
-              <a:t>15 Apr 2026</a:t>
+              <a:t>16 Apr 2026</a:t>
             </a:r>
           </a:p>
         </p:txBody>
@@ -5093,775 +4781,32 @@
   <p:clrMapOvr>
     <a:masterClrMapping/>
   </p:clrMapOvr>
+  <p:timing>
+    <p:tnLst>
+      <p:par>
+        <p:cTn id="1" dur="indefinite" restart="never" nodeType="tmRoot">
+          <p:childTnLst>
+            <p:video>
+              <p:cMediaNode vol="80000">
+                <p:cTn id="2" fill="hold" display="0">
+                  <p:stCondLst>
+                    <p:cond delay="indefinite"/>
+                  </p:stCondLst>
+                </p:cTn>
+                <p:tgtEl>
+                  <p:spTgt spid="4"/>
+                </p:tgtEl>
+              </p:cMediaNode>
+            </p:video>
+          </p:childTnLst>
+        </p:cTn>
+      </p:par>
+    </p:tnLst>
+  </p:timing>
 </p:sld>
 </file>
 
 <file path=ppt/slides/slide6.xml><?xml version="1.0" encoding="utf-8"?>
-<p:sld xmlns:a="http://schemas.openxmlformats.org/drawingml/2006/main" xmlns:p="http://schemas.openxmlformats.org/presentationml/2006/main" xmlns:r="http://schemas.openxmlformats.org/officeDocument/2006/relationships">
-  <p:cSld>
-    <p:bg>
-      <p:bgPr>
-        <a:solidFill>
-          <a:srgbClr val="FFF5F8"/>
-        </a:solidFill>
-        <a:effectLst/>
-      </p:bgPr>
-    </p:bg>
-    <p:spTree>
-      <p:nvGrpSpPr>
-        <p:cNvPr id="1" name=""/>
-        <p:cNvGrpSpPr/>
-        <p:nvPr/>
-      </p:nvGrpSpPr>
-      <p:grpSpPr/>
-      <p:sp>
-        <p:nvSpPr>
-          <p:cNvPr id="2" name="TextBox 1"/>
-          <p:cNvSpPr txBox="1"/>
-          <p:nvPr/>
-        </p:nvSpPr>
-        <p:spPr>
-          <a:xfrm>
-            <a:off x="640080" y="365760"/>
-            <a:ext cx="10789920" cy="1097280"/>
-          </a:xfrm>
-          <a:prstGeom prst="rect">
-            <a:avLst/>
-          </a:prstGeom>
-          <a:noFill/>
-        </p:spPr>
-        <p:txBody>
-          <a:bodyPr wrap="none">
-            <a:spAutoFit/>
-          </a:bodyPr>
-          <a:lstStyle/>
-          <a:p>
-            <a:r>
-              <a:rPr sz="3800" b="1">
-                <a:solidFill>
-                  <a:srgbClr val="0D2A3E"/>
-                </a:solidFill>
-              </a:rPr>
-              <a:t>Adaptive Relapse Risk Scoring (New)</a:t>
-            </a:r>
-          </a:p>
-        </p:txBody>
-      </p:sp>
-      <p:sp>
-        <p:nvSpPr>
-          <p:cNvPr id="3" name="TextBox 2"/>
-          <p:cNvSpPr txBox="1"/>
-          <p:nvPr/>
-        </p:nvSpPr>
-        <p:spPr>
-          <a:xfrm>
-            <a:off x="822960" y="1645920"/>
-            <a:ext cx="10972800" cy="4389120"/>
-          </a:xfrm>
-          <a:prstGeom prst="rect">
-            <a:avLst/>
-          </a:prstGeom>
-          <a:noFill/>
-        </p:spPr>
-        <p:txBody>
-          <a:bodyPr wrap="none">
-            <a:spAutoFit/>
-          </a:bodyPr>
-          <a:lstStyle/>
-          <a:p>
-            <a:pPr>
-              <a:spcAft>
-                <a:spcPts val="1200"/>
-              </a:spcAft>
-              <a:defRPr sz="2200">
-                <a:solidFill>
-                  <a:srgbClr val="2D2D2D"/>
-                </a:solidFill>
-              </a:defRPr>
-            </a:pPr>
-            <a:r>
-              <a:t>Risk score combines trend, time-of-day patterns, and device context.</a:t>
-            </a:r>
-          </a:p>
-          <a:p>
-            <a:pPr>
-              <a:spcAft>
-                <a:spcPts val="1200"/>
-              </a:spcAft>
-              <a:defRPr sz="2200">
-                <a:solidFill>
-                  <a:srgbClr val="2D2D2D"/>
-                </a:solidFill>
-              </a:defRPr>
-            </a:pPr>
-            <a:r>
-              <a:t>Risk levels: low, moderate, high, critical.</a:t>
-            </a:r>
-          </a:p>
-          <a:p>
-            <a:pPr>
-              <a:spcAft>
-                <a:spcPts val="1200"/>
-              </a:spcAft>
-              <a:defRPr sz="2200">
-                <a:solidFill>
-                  <a:srgbClr val="2D2D2D"/>
-                </a:solidFill>
-              </a:defRPr>
-            </a:pPr>
-            <a:r>
-              <a:t>API supports detailed risk diagnostics for each habit goal.</a:t>
-            </a:r>
-          </a:p>
-          <a:p>
-            <a:pPr>
-              <a:spcAft>
-                <a:spcPts val="1200"/>
-              </a:spcAft>
-              <a:defRPr sz="2200">
-                <a:solidFill>
-                  <a:srgbClr val="2D2D2D"/>
-                </a:solidFill>
-              </a:defRPr>
-            </a:pPr>
-            <a:r>
-              <a:t>Intervention prompts now intensify automatically as risk rises.</a:t>
-            </a:r>
-          </a:p>
-        </p:txBody>
-      </p:sp>
-      <p:sp>
-        <p:nvSpPr>
-          <p:cNvPr id="4" name="Rectangle 3"/>
-          <p:cNvSpPr/>
-          <p:nvPr/>
-        </p:nvSpPr>
-        <p:spPr>
-          <a:xfrm>
-            <a:off x="548640" y="6263640"/>
-            <a:ext cx="11064240" cy="18288"/>
-          </a:xfrm>
-          <a:prstGeom prst="rect">
-            <a:avLst/>
-          </a:prstGeom>
-          <a:solidFill>
-            <a:srgbClr val="1A86D6"/>
-          </a:solidFill>
-          <a:ln>
-            <a:noFill/>
-          </a:ln>
-        </p:spPr>
-        <p:style>
-          <a:lnRef idx="1">
-            <a:schemeClr val="accent1"/>
-          </a:lnRef>
-          <a:fillRef idx="3">
-            <a:schemeClr val="accent1"/>
-          </a:fillRef>
-          <a:effectRef idx="2">
-            <a:schemeClr val="accent1"/>
-          </a:effectRef>
-          <a:fontRef idx="minor">
-            <a:schemeClr val="lt1"/>
-          </a:fontRef>
-        </p:style>
-        <p:txBody>
-          <a:bodyPr rtlCol="0" anchor="ctr"/>
-          <a:lstStyle/>
-          <a:p>
-            <a:pPr algn="ctr"/>
-          </a:p>
-        </p:txBody>
-      </p:sp>
-      <p:sp>
-        <p:nvSpPr>
-          <p:cNvPr id="5" name="TextBox 4"/>
-          <p:cNvSpPr txBox="1"/>
-          <p:nvPr/>
-        </p:nvSpPr>
-        <p:spPr>
-          <a:xfrm>
-            <a:off x="640080" y="6355080"/>
-            <a:ext cx="7772400" cy="365760"/>
-          </a:xfrm>
-          <a:prstGeom prst="rect">
-            <a:avLst/>
-          </a:prstGeom>
-          <a:noFill/>
-        </p:spPr>
-        <p:txBody>
-          <a:bodyPr wrap="none">
-            <a:spAutoFit/>
-          </a:bodyPr>
-          <a:lstStyle/>
-          <a:p>
-            <a:pPr>
-              <a:defRPr sz="1200">
-                <a:solidFill>
-                  <a:srgbClr val="5A5A5A"/>
-                </a:solidFill>
-              </a:defRPr>
-            </a:pPr>
-            <a:r>
-              <a:t>Myriad | Privacy-first mindful habit tracking</a:t>
-            </a:r>
-          </a:p>
-        </p:txBody>
-      </p:sp>
-      <p:sp>
-        <p:nvSpPr>
-          <p:cNvPr id="6" name="TextBox 5"/>
-          <p:cNvSpPr txBox="1"/>
-          <p:nvPr/>
-        </p:nvSpPr>
-        <p:spPr>
-          <a:xfrm>
-            <a:off x="8869680" y="6355080"/>
-            <a:ext cx="2651760" cy="365760"/>
-          </a:xfrm>
-          <a:prstGeom prst="rect">
-            <a:avLst/>
-          </a:prstGeom>
-          <a:noFill/>
-        </p:spPr>
-        <p:txBody>
-          <a:bodyPr wrap="none">
-            <a:spAutoFit/>
-          </a:bodyPr>
-          <a:lstStyle/>
-          <a:p>
-            <a:pPr algn="ctr">
-              <a:defRPr sz="1200">
-                <a:solidFill>
-                  <a:srgbClr val="5A5A5A"/>
-                </a:solidFill>
-              </a:defRPr>
-            </a:pPr>
-            <a:r>
-              <a:t>15 Apr 2026</a:t>
-            </a:r>
-          </a:p>
-        </p:txBody>
-      </p:sp>
-    </p:spTree>
-  </p:cSld>
-  <p:clrMapOvr>
-    <a:masterClrMapping/>
-  </p:clrMapOvr>
-</p:sld>
-</file>
-
-<file path=ppt/slides/slide7.xml><?xml version="1.0" encoding="utf-8"?>
-<p:sld xmlns:a="http://schemas.openxmlformats.org/drawingml/2006/main" xmlns:p="http://schemas.openxmlformats.org/presentationml/2006/main" xmlns:r="http://schemas.openxmlformats.org/officeDocument/2006/relationships">
-  <p:cSld>
-    <p:bg>
-      <p:bgPr>
-        <a:solidFill>
-          <a:srgbClr val="F6FFFA"/>
-        </a:solidFill>
-        <a:effectLst/>
-      </p:bgPr>
-    </p:bg>
-    <p:spTree>
-      <p:nvGrpSpPr>
-        <p:cNvPr id="1" name=""/>
-        <p:cNvGrpSpPr/>
-        <p:nvPr/>
-      </p:nvGrpSpPr>
-      <p:grpSpPr/>
-      <p:sp>
-        <p:nvSpPr>
-          <p:cNvPr id="2" name="TextBox 1"/>
-          <p:cNvSpPr txBox="1"/>
-          <p:nvPr/>
-        </p:nvSpPr>
-        <p:spPr>
-          <a:xfrm>
-            <a:off x="640080" y="365760"/>
-            <a:ext cx="10789920" cy="1097280"/>
-          </a:xfrm>
-          <a:prstGeom prst="rect">
-            <a:avLst/>
-          </a:prstGeom>
-          <a:noFill/>
-        </p:spPr>
-        <p:txBody>
-          <a:bodyPr wrap="none">
-            <a:spAutoFit/>
-          </a:bodyPr>
-          <a:lstStyle/>
-          <a:p>
-            <a:r>
-              <a:rPr sz="3800" b="1">
-                <a:solidFill>
-                  <a:srgbClr val="0D2A3E"/>
-                </a:solidFill>
-              </a:rPr>
-              <a:t>Notification Nudges in Electron (New)</a:t>
-            </a:r>
-          </a:p>
-        </p:txBody>
-      </p:sp>
-      <p:sp>
-        <p:nvSpPr>
-          <p:cNvPr id="3" name="TextBox 2"/>
-          <p:cNvSpPr txBox="1"/>
-          <p:nvPr/>
-        </p:nvSpPr>
-        <p:spPr>
-          <a:xfrm>
-            <a:off x="822960" y="1645920"/>
-            <a:ext cx="10972800" cy="4389120"/>
-          </a:xfrm>
-          <a:prstGeom prst="rect">
-            <a:avLst/>
-          </a:prstGeom>
-          <a:noFill/>
-        </p:spPr>
-        <p:txBody>
-          <a:bodyPr wrap="none">
-            <a:spAutoFit/>
-          </a:bodyPr>
-          <a:lstStyle/>
-          <a:p>
-            <a:pPr>
-              <a:spcAft>
-                <a:spcPts val="1200"/>
-              </a:spcAft>
-              <a:defRPr sz="2200">
-                <a:solidFill>
-                  <a:srgbClr val="2D2D2D"/>
-                </a:solidFill>
-              </a:defRPr>
-            </a:pPr>
-            <a:r>
-              <a:t>Renderer computes approaching-limit risk and triggers IPC notifications.</a:t>
-            </a:r>
-          </a:p>
-          <a:p>
-            <a:pPr>
-              <a:spcAft>
-                <a:spcPts val="1200"/>
-              </a:spcAft>
-              <a:defRPr sz="2200">
-                <a:solidFill>
-                  <a:srgbClr val="2D2D2D"/>
-                </a:solidFill>
-              </a:defRPr>
-            </a:pPr>
-            <a:r>
-              <a:t>Main process displays native OS notifications and click-to-focus behavior.</a:t>
-            </a:r>
-          </a:p>
-          <a:p>
-            <a:pPr>
-              <a:spcAft>
-                <a:spcPts val="1200"/>
-              </a:spcAft>
-              <a:defRPr sz="2200">
-                <a:solidFill>
-                  <a:srgbClr val="2D2D2D"/>
-                </a:solidFill>
-              </a:defRPr>
-            </a:pPr>
-            <a:r>
-              <a:t>Nudge frequency is throttled to avoid alert fatigue.</a:t>
-            </a:r>
-          </a:p>
-          <a:p>
-            <a:pPr>
-              <a:spcAft>
-                <a:spcPts val="1200"/>
-              </a:spcAft>
-              <a:defRPr sz="2200">
-                <a:solidFill>
-                  <a:srgbClr val="2D2D2D"/>
-                </a:solidFill>
-              </a:defRPr>
-            </a:pPr>
-            <a:r>
-              <a:t>Designed to intervene before limit breaches occur.</a:t>
-            </a:r>
-          </a:p>
-        </p:txBody>
-      </p:sp>
-      <p:sp>
-        <p:nvSpPr>
-          <p:cNvPr id="4" name="Rectangle 3"/>
-          <p:cNvSpPr/>
-          <p:nvPr/>
-        </p:nvSpPr>
-        <p:spPr>
-          <a:xfrm>
-            <a:off x="548640" y="6263640"/>
-            <a:ext cx="11064240" cy="18288"/>
-          </a:xfrm>
-          <a:prstGeom prst="rect">
-            <a:avLst/>
-          </a:prstGeom>
-          <a:solidFill>
-            <a:srgbClr val="1A86D6"/>
-          </a:solidFill>
-          <a:ln>
-            <a:noFill/>
-          </a:ln>
-        </p:spPr>
-        <p:style>
-          <a:lnRef idx="1">
-            <a:schemeClr val="accent1"/>
-          </a:lnRef>
-          <a:fillRef idx="3">
-            <a:schemeClr val="accent1"/>
-          </a:fillRef>
-          <a:effectRef idx="2">
-            <a:schemeClr val="accent1"/>
-          </a:effectRef>
-          <a:fontRef idx="minor">
-            <a:schemeClr val="lt1"/>
-          </a:fontRef>
-        </p:style>
-        <p:txBody>
-          <a:bodyPr rtlCol="0" anchor="ctr"/>
-          <a:lstStyle/>
-          <a:p>
-            <a:pPr algn="ctr"/>
-          </a:p>
-        </p:txBody>
-      </p:sp>
-      <p:sp>
-        <p:nvSpPr>
-          <p:cNvPr id="5" name="TextBox 4"/>
-          <p:cNvSpPr txBox="1"/>
-          <p:nvPr/>
-        </p:nvSpPr>
-        <p:spPr>
-          <a:xfrm>
-            <a:off x="640080" y="6355080"/>
-            <a:ext cx="7772400" cy="365760"/>
-          </a:xfrm>
-          <a:prstGeom prst="rect">
-            <a:avLst/>
-          </a:prstGeom>
-          <a:noFill/>
-        </p:spPr>
-        <p:txBody>
-          <a:bodyPr wrap="none">
-            <a:spAutoFit/>
-          </a:bodyPr>
-          <a:lstStyle/>
-          <a:p>
-            <a:pPr>
-              <a:defRPr sz="1200">
-                <a:solidFill>
-                  <a:srgbClr val="5A5A5A"/>
-                </a:solidFill>
-              </a:defRPr>
-            </a:pPr>
-            <a:r>
-              <a:t>Myriad | Privacy-first mindful habit tracking</a:t>
-            </a:r>
-          </a:p>
-        </p:txBody>
-      </p:sp>
-      <p:sp>
-        <p:nvSpPr>
-          <p:cNvPr id="6" name="TextBox 5"/>
-          <p:cNvSpPr txBox="1"/>
-          <p:nvPr/>
-        </p:nvSpPr>
-        <p:spPr>
-          <a:xfrm>
-            <a:off x="8869680" y="6355080"/>
-            <a:ext cx="2651760" cy="365760"/>
-          </a:xfrm>
-          <a:prstGeom prst="rect">
-            <a:avLst/>
-          </a:prstGeom>
-          <a:noFill/>
-        </p:spPr>
-        <p:txBody>
-          <a:bodyPr wrap="none">
-            <a:spAutoFit/>
-          </a:bodyPr>
-          <a:lstStyle/>
-          <a:p>
-            <a:pPr algn="ctr">
-              <a:defRPr sz="1200">
-                <a:solidFill>
-                  <a:srgbClr val="5A5A5A"/>
-                </a:solidFill>
-              </a:defRPr>
-            </a:pPr>
-            <a:r>
-              <a:t>15 Apr 2026</a:t>
-            </a:r>
-          </a:p>
-        </p:txBody>
-      </p:sp>
-    </p:spTree>
-  </p:cSld>
-  <p:clrMapOvr>
-    <a:masterClrMapping/>
-  </p:clrMapOvr>
-</p:sld>
-</file>
-
-<file path=ppt/slides/slide8.xml><?xml version="1.0" encoding="utf-8"?>
-<p:sld xmlns:a="http://schemas.openxmlformats.org/drawingml/2006/main" xmlns:p="http://schemas.openxmlformats.org/presentationml/2006/main" xmlns:r="http://schemas.openxmlformats.org/officeDocument/2006/relationships">
-  <p:cSld>
-    <p:bg>
-      <p:bgPr>
-        <a:solidFill>
-          <a:srgbClr val="FAFAFF"/>
-        </a:solidFill>
-        <a:effectLst/>
-      </p:bgPr>
-    </p:bg>
-    <p:spTree>
-      <p:nvGrpSpPr>
-        <p:cNvPr id="1" name=""/>
-        <p:cNvGrpSpPr/>
-        <p:nvPr/>
-      </p:nvGrpSpPr>
-      <p:grpSpPr/>
-      <p:sp>
-        <p:nvSpPr>
-          <p:cNvPr id="2" name="TextBox 1"/>
-          <p:cNvSpPr txBox="1"/>
-          <p:nvPr/>
-        </p:nvSpPr>
-        <p:spPr>
-          <a:xfrm>
-            <a:off x="640080" y="365760"/>
-            <a:ext cx="10789920" cy="1097280"/>
-          </a:xfrm>
-          <a:prstGeom prst="rect">
-            <a:avLst/>
-          </a:prstGeom>
-          <a:noFill/>
-        </p:spPr>
-        <p:txBody>
-          <a:bodyPr wrap="none">
-            <a:spAutoFit/>
-          </a:bodyPr>
-          <a:lstStyle/>
-          <a:p>
-            <a:r>
-              <a:rPr sz="3800" b="1">
-                <a:solidFill>
-                  <a:srgbClr val="0D2A3E"/>
-                </a:solidFill>
-              </a:rPr>
-              <a:t>Validation and Results</a:t>
-            </a:r>
-          </a:p>
-        </p:txBody>
-      </p:sp>
-      <p:sp>
-        <p:nvSpPr>
-          <p:cNvPr id="3" name="TextBox 2"/>
-          <p:cNvSpPr txBox="1"/>
-          <p:nvPr/>
-        </p:nvSpPr>
-        <p:spPr>
-          <a:xfrm>
-            <a:off x="822960" y="1645920"/>
-            <a:ext cx="10972800" cy="4389120"/>
-          </a:xfrm>
-          <a:prstGeom prst="rect">
-            <a:avLst/>
-          </a:prstGeom>
-          <a:noFill/>
-        </p:spPr>
-        <p:txBody>
-          <a:bodyPr wrap="none">
-            <a:spAutoFit/>
-          </a:bodyPr>
-          <a:lstStyle/>
-          <a:p>
-            <a:pPr>
-              <a:spcAft>
-                <a:spcPts val="1200"/>
-              </a:spcAft>
-              <a:defRPr sz="2200">
-                <a:solidFill>
-                  <a:srgbClr val="2D2D2D"/>
-                </a:solidFill>
-              </a:defRPr>
-            </a:pPr>
-            <a:r>
-              <a:t>Node integration tests: 14/14 passed.</a:t>
-            </a:r>
-          </a:p>
-          <a:p>
-            <a:pPr>
-              <a:spcAft>
-                <a:spcPts val="1200"/>
-              </a:spcAft>
-              <a:defRPr sz="2200">
-                <a:solidFill>
-                  <a:srgbClr val="2D2D2D"/>
-                </a:solidFill>
-              </a:defRPr>
-            </a:pPr>
-            <a:r>
-              <a:t>Playwright E2E test suite: passed.</a:t>
-            </a:r>
-          </a:p>
-          <a:p>
-            <a:pPr>
-              <a:spcAft>
-                <a:spcPts val="1200"/>
-              </a:spcAft>
-              <a:defRPr sz="2200">
-                <a:solidFill>
-                  <a:srgbClr val="2D2D2D"/>
-                </a:solidFill>
-              </a:defRPr>
-            </a:pPr>
-            <a:r>
-              <a:t>iOS test pipeline restored: npm run test:ios now succeeds.</a:t>
-            </a:r>
-          </a:p>
-          <a:p>
-            <a:pPr>
-              <a:spcAft>
-                <a:spcPts val="1200"/>
-              </a:spcAft>
-              <a:defRPr sz="2200">
-                <a:solidFill>
-                  <a:srgbClr val="2D2D2D"/>
-                </a:solidFill>
-              </a:defRPr>
-            </a:pPr>
-            <a:r>
-              <a:t>Usability pilot: SUS mean 73.8/100 (n=2).</a:t>
-            </a:r>
-          </a:p>
-        </p:txBody>
-      </p:sp>
-      <p:sp>
-        <p:nvSpPr>
-          <p:cNvPr id="4" name="Rectangle 3"/>
-          <p:cNvSpPr/>
-          <p:nvPr/>
-        </p:nvSpPr>
-        <p:spPr>
-          <a:xfrm>
-            <a:off x="548640" y="6263640"/>
-            <a:ext cx="11064240" cy="18288"/>
-          </a:xfrm>
-          <a:prstGeom prst="rect">
-            <a:avLst/>
-          </a:prstGeom>
-          <a:solidFill>
-            <a:srgbClr val="1A86D6"/>
-          </a:solidFill>
-          <a:ln>
-            <a:noFill/>
-          </a:ln>
-        </p:spPr>
-        <p:style>
-          <a:lnRef idx="1">
-            <a:schemeClr val="accent1"/>
-          </a:lnRef>
-          <a:fillRef idx="3">
-            <a:schemeClr val="accent1"/>
-          </a:fillRef>
-          <a:effectRef idx="2">
-            <a:schemeClr val="accent1"/>
-          </a:effectRef>
-          <a:fontRef idx="minor">
-            <a:schemeClr val="lt1"/>
-          </a:fontRef>
-        </p:style>
-        <p:txBody>
-          <a:bodyPr rtlCol="0" anchor="ctr"/>
-          <a:lstStyle/>
-          <a:p>
-            <a:pPr algn="ctr"/>
-          </a:p>
-        </p:txBody>
-      </p:sp>
-      <p:sp>
-        <p:nvSpPr>
-          <p:cNvPr id="5" name="TextBox 4"/>
-          <p:cNvSpPr txBox="1"/>
-          <p:nvPr/>
-        </p:nvSpPr>
-        <p:spPr>
-          <a:xfrm>
-            <a:off x="640080" y="6355080"/>
-            <a:ext cx="7772400" cy="365760"/>
-          </a:xfrm>
-          <a:prstGeom prst="rect">
-            <a:avLst/>
-          </a:prstGeom>
-          <a:noFill/>
-        </p:spPr>
-        <p:txBody>
-          <a:bodyPr wrap="none">
-            <a:spAutoFit/>
-          </a:bodyPr>
-          <a:lstStyle/>
-          <a:p>
-            <a:pPr>
-              <a:defRPr sz="1200">
-                <a:solidFill>
-                  <a:srgbClr val="5A5A5A"/>
-                </a:solidFill>
-              </a:defRPr>
-            </a:pPr>
-            <a:r>
-              <a:t>Myriad | Privacy-first mindful habit tracking</a:t>
-            </a:r>
-          </a:p>
-        </p:txBody>
-      </p:sp>
-      <p:sp>
-        <p:nvSpPr>
-          <p:cNvPr id="6" name="TextBox 5"/>
-          <p:cNvSpPr txBox="1"/>
-          <p:nvPr/>
-        </p:nvSpPr>
-        <p:spPr>
-          <a:xfrm>
-            <a:off x="8869680" y="6355080"/>
-            <a:ext cx="2651760" cy="365760"/>
-          </a:xfrm>
-          <a:prstGeom prst="rect">
-            <a:avLst/>
-          </a:prstGeom>
-          <a:noFill/>
-        </p:spPr>
-        <p:txBody>
-          <a:bodyPr wrap="none">
-            <a:spAutoFit/>
-          </a:bodyPr>
-          <a:lstStyle/>
-          <a:p>
-            <a:pPr algn="ctr">
-              <a:defRPr sz="1200">
-                <a:solidFill>
-                  <a:srgbClr val="5A5A5A"/>
-                </a:solidFill>
-              </a:defRPr>
-            </a:pPr>
-            <a:r>
-              <a:t>15 Apr 2026</a:t>
-            </a:r>
-          </a:p>
-        </p:txBody>
-      </p:sp>
-    </p:spTree>
-  </p:cSld>
-  <p:clrMapOvr>
-    <a:masterClrMapping/>
-  </p:clrMapOvr>
-</p:sld>
-</file>
-
-<file path=ppt/slides/slide9.xml><?xml version="1.0" encoding="utf-8"?>
 <p:sld xmlns:a="http://schemas.openxmlformats.org/drawingml/2006/main" xmlns:p="http://schemas.openxmlformats.org/presentationml/2006/main" xmlns:r="http://schemas.openxmlformats.org/officeDocument/2006/relationships">
   <p:cSld>
     <p:bg>
@@ -5887,8 +4832,8 @@
         </p:nvSpPr>
         <p:spPr>
           <a:xfrm>
-            <a:off x="640080" y="365760"/>
-            <a:ext cx="10789920" cy="1097280"/>
+            <a:off x="502920" y="320040"/>
+            <a:ext cx="11155680" cy="731520"/>
           </a:xfrm>
           <a:prstGeom prst="rect">
             <a:avLst/>
@@ -5902,12 +4847,12 @@
           <a:lstStyle/>
           <a:p>
             <a:r>
-              <a:rPr sz="3800" b="1">
+              <a:rPr sz="3400" b="1">
                 <a:solidFill>
                   <a:srgbClr val="0D2A3E"/>
                 </a:solidFill>
               </a:rPr>
-              <a:t>iOS Recovery and Testability</a:t>
+              <a:t>Video Walkthrough: iOS Simulator</a:t>
             </a:r>
           </a:p>
         </p:txBody>
@@ -5920,8 +4865,94 @@
         </p:nvSpPr>
         <p:spPr>
           <a:xfrm>
-            <a:off x="822960" y="1645920"/>
-            <a:ext cx="10972800" cy="4389120"/>
+            <a:off x="640080" y="1188720"/>
+            <a:ext cx="3840480" cy="5303520"/>
+          </a:xfrm>
+          <a:prstGeom prst="rect">
+            <a:avLst/>
+          </a:prstGeom>
+          <a:noFill/>
+        </p:spPr>
+        <p:txBody>
+          <a:bodyPr wrap="square">
+            <a:spAutoFit/>
+          </a:bodyPr>
+          <a:lstStyle/>
+          <a:p>
+            <a:pPr>
+              <a:spcAft>
+                <a:spcPts val="1000"/>
+              </a:spcAft>
+              <a:defRPr sz="2000">
+                <a:solidFill>
+                  <a:srgbClr val="2D2D2D"/>
+                </a:solidFill>
+              </a:defRPr>
+            </a:pPr>
+            <a:r>
+              <a:t>Embedded simulator clip.</a:t>
+            </a:r>
+          </a:p>
+          <a:p>
+            <a:pPr>
+              <a:spcAft>
+                <a:spcPts val="1000"/>
+              </a:spcAft>
+              <a:defRPr sz="2000">
+                <a:solidFill>
+                  <a:srgbClr val="2D2D2D"/>
+                </a:solidFill>
+              </a:defRPr>
+            </a:pPr>
+            <a:r>
+              <a:t>Shows the restored iOS test target and device flow.</a:t>
+            </a:r>
+          </a:p>
+        </p:txBody>
+      </p:sp>
+      <p:pic>
+        <p:nvPicPr>
+          <p:cNvPr id="4" name="myriad-ios-simulator-demo.mp4">
+            <a:hlinkClick r:id="" action="ppaction://media"/>
+          </p:cNvPr>
+          <p:cNvPicPr>
+            <a:picLocks noChangeAspect="1"/>
+          </p:cNvPicPr>
+          <p:nvPr>
+            <a:videoFile r:link="rId3"/>
+            <p:extLst>
+              <p:ext uri="{DAA4B4D4-6D71-4841-9C94-3DE7FCFB9230}">
+                <p14:media xmlns:p14="http://schemas.microsoft.com/office/powerpoint/2010/main" r:embed="rId2"/>
+              </p:ext>
+            </p:extLst>
+          </p:nvPr>
+        </p:nvPicPr>
+        <p:blipFill>
+          <a:blip r:embed="rId4"/>
+          <a:stretch>
+            <a:fillRect/>
+          </a:stretch>
+        </p:blipFill>
+        <p:spPr>
+          <a:xfrm>
+            <a:off x="4343400" y="1143000"/>
+            <a:ext cx="7223760" cy="4069080"/>
+          </a:xfrm>
+          <a:prstGeom prst="rect">
+            <a:avLst/>
+          </a:prstGeom>
+        </p:spPr>
+      </p:pic>
+      <p:sp>
+        <p:nvSpPr>
+          <p:cNvPr id="5" name="TextBox 4"/>
+          <p:cNvSpPr txBox="1"/>
+          <p:nvPr/>
+        </p:nvSpPr>
+        <p:spPr>
+          <a:xfrm>
+            <a:off x="4343400" y="5349240"/>
+            <a:ext cx="7223760" cy="320040"/>
           </a:xfrm>
           <a:prstGeom prst="rect">
             <a:avLst/>
@@ -5934,77 +4965,29 @@
           </a:bodyPr>
           <a:lstStyle/>
           <a:p>
-            <a:pPr>
-              <a:spcAft>
-                <a:spcPts val="1200"/>
-              </a:spcAft>
-              <a:defRPr sz="2200">
-                <a:solidFill>
-                  <a:srgbClr val="2D2D2D"/>
+            <a:pPr algn="l">
+              <a:defRPr sz="1100">
+                <a:solidFill>
+                  <a:srgbClr val="5C5C5C"/>
                 </a:solidFill>
               </a:defRPr>
             </a:pPr>
             <a:r>
-              <a:t>Recovered from missing project state by scaffolding source-first iOS structure.</a:t>
-            </a:r>
-          </a:p>
-          <a:p>
-            <a:pPr>
-              <a:spcAft>
-                <a:spcPts val="1200"/>
-              </a:spcAft>
-              <a:defRPr sz="2200">
-                <a:solidFill>
-                  <a:srgbClr val="2D2D2D"/>
-                </a:solidFill>
-              </a:defRPr>
-            </a:pPr>
-            <a:r>
-              <a:t>Added app target, widget extension target, unit tests, and UI tests.</a:t>
-            </a:r>
-          </a:p>
-          <a:p>
-            <a:pPr>
-              <a:spcAft>
-                <a:spcPts val="1200"/>
-              </a:spcAft>
-              <a:defRPr sz="2200">
-                <a:solidFill>
-                  <a:srgbClr val="2D2D2D"/>
-                </a:solidFill>
-              </a:defRPr>
-            </a:pPr>
-            <a:r>
-              <a:t>Added automated regeneration via xcodegen when project file is missing.</a:t>
-            </a:r>
-          </a:p>
-          <a:p>
-            <a:pPr>
-              <a:spcAft>
-                <a:spcPts val="1200"/>
-              </a:spcAft>
-              <a:defRPr sz="2200">
-                <a:solidFill>
-                  <a:srgbClr val="2D2D2D"/>
-                </a:solidFill>
-              </a:defRPr>
-            </a:pPr>
-            <a:r>
-              <a:t>test:ios script now resolves an installed simulator automatically.</a:t>
-            </a:r>
-          </a:p>
-        </p:txBody>
-      </p:sp>
-      <p:sp>
-        <p:nvSpPr>
-          <p:cNvPr id="4" name="Rectangle 3"/>
+              <a:t>Embedded video clip</a:t>
+            </a:r>
+          </a:p>
+        </p:txBody>
+      </p:sp>
+      <p:sp>
+        <p:nvSpPr>
+          <p:cNvPr id="6" name="Rectangle 5"/>
           <p:cNvSpPr/>
           <p:nvPr/>
         </p:nvSpPr>
         <p:spPr>
           <a:xfrm>
-            <a:off x="548640" y="6263640"/>
-            <a:ext cx="11064240" cy="18288"/>
+            <a:off x="502920" y="6309360"/>
+            <a:ext cx="11201400" cy="27432"/>
           </a:xfrm>
           <a:prstGeom prst="rect">
             <a:avLst/>
@@ -6040,14 +5023,272 @@
       </p:sp>
       <p:sp>
         <p:nvSpPr>
+          <p:cNvPr id="7" name="TextBox 6"/>
+          <p:cNvSpPr txBox="1"/>
+          <p:nvPr/>
+        </p:nvSpPr>
+        <p:spPr>
+          <a:xfrm>
+            <a:off x="502920" y="6400800"/>
+            <a:ext cx="6400800" cy="228600"/>
+          </a:xfrm>
+          <a:prstGeom prst="rect">
+            <a:avLst/>
+          </a:prstGeom>
+          <a:noFill/>
+        </p:spPr>
+        <p:txBody>
+          <a:bodyPr wrap="none">
+            <a:spAutoFit/>
+          </a:bodyPr>
+          <a:lstStyle/>
+          <a:p>
+            <a:pPr>
+              <a:defRPr sz="1000">
+                <a:solidFill>
+                  <a:srgbClr val="5C5C5C"/>
+                </a:solidFill>
+              </a:defRPr>
+            </a:pPr>
+            <a:r>
+              <a:t>Myriad</a:t>
+            </a:r>
+          </a:p>
+        </p:txBody>
+      </p:sp>
+      <p:sp>
+        <p:nvSpPr>
+          <p:cNvPr id="8" name="TextBox 7"/>
+          <p:cNvSpPr txBox="1"/>
+          <p:nvPr/>
+        </p:nvSpPr>
+        <p:spPr>
+          <a:xfrm>
+            <a:off x="9966960" y="6400800"/>
+            <a:ext cx="1737360" cy="228600"/>
+          </a:xfrm>
+          <a:prstGeom prst="rect">
+            <a:avLst/>
+          </a:prstGeom>
+          <a:noFill/>
+        </p:spPr>
+        <p:txBody>
+          <a:bodyPr wrap="none">
+            <a:spAutoFit/>
+          </a:bodyPr>
+          <a:lstStyle/>
+          <a:p>
+            <a:pPr algn="ctr">
+              <a:defRPr sz="1000">
+                <a:solidFill>
+                  <a:srgbClr val="5C5C5C"/>
+                </a:solidFill>
+              </a:defRPr>
+            </a:pPr>
+            <a:r>
+              <a:t>16 Apr 2026</a:t>
+            </a:r>
+          </a:p>
+        </p:txBody>
+      </p:sp>
+    </p:spTree>
+  </p:cSld>
+  <p:clrMapOvr>
+    <a:masterClrMapping/>
+  </p:clrMapOvr>
+  <p:timing>
+    <p:tnLst>
+      <p:par>
+        <p:cTn id="1" dur="indefinite" restart="never" nodeType="tmRoot">
+          <p:childTnLst>
+            <p:video>
+              <p:cMediaNode vol="80000">
+                <p:cTn id="2" fill="hold" display="0">
+                  <p:stCondLst>
+                    <p:cond delay="indefinite"/>
+                  </p:stCondLst>
+                </p:cTn>
+                <p:tgtEl>
+                  <p:spTgt spid="4"/>
+                </p:tgtEl>
+              </p:cMediaNode>
+            </p:video>
+          </p:childTnLst>
+        </p:cTn>
+      </p:par>
+    </p:tnLst>
+  </p:timing>
+</p:sld>
+</file>
+
+<file path=ppt/slides/slide7.xml><?xml version="1.0" encoding="utf-8"?>
+<p:sld xmlns:a="http://schemas.openxmlformats.org/drawingml/2006/main" xmlns:p="http://schemas.openxmlformats.org/presentationml/2006/main" xmlns:r="http://schemas.openxmlformats.org/officeDocument/2006/relationships">
+  <p:cSld>
+    <p:bg>
+      <p:bgPr>
+        <a:solidFill>
+          <a:srgbClr val="FCFCFF"/>
+        </a:solidFill>
+        <a:effectLst/>
+      </p:bgPr>
+    </p:bg>
+    <p:spTree>
+      <p:nvGrpSpPr>
+        <p:cNvPr id="1" name=""/>
+        <p:cNvGrpSpPr/>
+        <p:nvPr/>
+      </p:nvGrpSpPr>
+      <p:grpSpPr/>
+      <p:sp>
+        <p:nvSpPr>
+          <p:cNvPr id="2" name="TextBox 1"/>
+          <p:cNvSpPr txBox="1"/>
+          <p:nvPr/>
+        </p:nvSpPr>
+        <p:spPr>
+          <a:xfrm>
+            <a:off x="502920" y="320040"/>
+            <a:ext cx="11155680" cy="731520"/>
+          </a:xfrm>
+          <a:prstGeom prst="rect">
+            <a:avLst/>
+          </a:prstGeom>
+          <a:noFill/>
+        </p:spPr>
+        <p:txBody>
+          <a:bodyPr wrap="none">
+            <a:spAutoFit/>
+          </a:bodyPr>
+          <a:lstStyle/>
+          <a:p>
+            <a:r>
+              <a:rPr sz="3400" b="1">
+                <a:solidFill>
+                  <a:srgbClr val="0D2A3E"/>
+                </a:solidFill>
+              </a:rPr>
+              <a:t>Validation and Results</a:t>
+            </a:r>
+          </a:p>
+        </p:txBody>
+      </p:sp>
+      <p:sp>
+        <p:nvSpPr>
+          <p:cNvPr id="3" name="TextBox 2"/>
+          <p:cNvSpPr txBox="1"/>
+          <p:nvPr/>
+        </p:nvSpPr>
+        <p:spPr>
+          <a:xfrm>
+            <a:off x="685800" y="1234440"/>
+            <a:ext cx="5394960" cy="5303520"/>
+          </a:xfrm>
+          <a:prstGeom prst="rect">
+            <a:avLst/>
+          </a:prstGeom>
+          <a:noFill/>
+        </p:spPr>
+        <p:txBody>
+          <a:bodyPr wrap="square">
+            <a:spAutoFit/>
+          </a:bodyPr>
+          <a:lstStyle/>
+          <a:p>
+            <a:pPr>
+              <a:spcAft>
+                <a:spcPts val="1000"/>
+              </a:spcAft>
+              <a:defRPr sz="1900">
+                <a:solidFill>
+                  <a:srgbClr val="2D2D2D"/>
+                </a:solidFill>
+              </a:defRPr>
+            </a:pPr>
+            <a:r>
+              <a:t>Node tests: 14/14 passed.</a:t>
+            </a:r>
+          </a:p>
+          <a:p>
+            <a:pPr>
+              <a:spcAft>
+                <a:spcPts val="1000"/>
+              </a:spcAft>
+              <a:defRPr sz="1900">
+                <a:solidFill>
+                  <a:srgbClr val="2D2D2D"/>
+                </a:solidFill>
+              </a:defRPr>
+            </a:pPr>
+            <a:r>
+              <a:t>E2E UI test: passed.</a:t>
+            </a:r>
+          </a:p>
+          <a:p>
+            <a:pPr>
+              <a:spcAft>
+                <a:spcPts val="1000"/>
+              </a:spcAft>
+              <a:defRPr sz="1900">
+                <a:solidFill>
+                  <a:srgbClr val="2D2D2D"/>
+                </a:solidFill>
+              </a:defRPr>
+            </a:pPr>
+            <a:r>
+              <a:t>iOS build/test flow: restored and passing via test:ios.</a:t>
+            </a:r>
+          </a:p>
+          <a:p>
+            <a:pPr>
+              <a:spcAft>
+                <a:spcPts val="1000"/>
+              </a:spcAft>
+              <a:defRPr sz="1900">
+                <a:solidFill>
+                  <a:srgbClr val="2D2D2D"/>
+                </a:solidFill>
+              </a:defRPr>
+            </a:pPr>
+            <a:r>
+              <a:t>Usability pilot: SUS 73.8/100 with positive qualitative feedback.</a:t>
+            </a:r>
+          </a:p>
+        </p:txBody>
+      </p:sp>
+      <p:pic>
+        <p:nvPicPr>
+          <p:cNvPr id="4" name="Picture 3" descr="poc_test_outcomes.png"/>
+          <p:cNvPicPr>
+            <a:picLocks noChangeAspect="1"/>
+          </p:cNvPicPr>
+          <p:nvPr/>
+        </p:nvPicPr>
+        <p:blipFill>
+          <a:blip r:embed="rId2"/>
+          <a:stretch>
+            <a:fillRect/>
+          </a:stretch>
+        </p:blipFill>
+        <p:spPr>
+          <a:xfrm>
+            <a:off x="6217920" y="1234440"/>
+            <a:ext cx="5074920" cy="3171825"/>
+          </a:xfrm>
+          <a:prstGeom prst="rect">
+            <a:avLst/>
+          </a:prstGeom>
+        </p:spPr>
+      </p:pic>
+      <p:sp>
+        <p:nvSpPr>
           <p:cNvPr id="5" name="TextBox 4"/>
           <p:cNvSpPr txBox="1"/>
           <p:nvPr/>
         </p:nvSpPr>
         <p:spPr>
           <a:xfrm>
-            <a:off x="640080" y="6355080"/>
-            <a:ext cx="7772400" cy="365760"/>
+            <a:off x="6217920" y="5440680"/>
+            <a:ext cx="5074920" cy="320040"/>
           </a:xfrm>
           <a:prstGeom prst="rect">
             <a:avLst/>
@@ -6060,15 +5301,318 @@
           </a:bodyPr>
           <a:lstStyle/>
           <a:p>
+            <a:pPr algn="l">
+              <a:defRPr sz="1100">
+                <a:solidFill>
+                  <a:srgbClr val="5C5C5C"/>
+                </a:solidFill>
+              </a:defRPr>
+            </a:pPr>
+            <a:r>
+              <a:t>Evidence summary screenshot</a:t>
+            </a:r>
+          </a:p>
+        </p:txBody>
+      </p:sp>
+      <p:sp>
+        <p:nvSpPr>
+          <p:cNvPr id="6" name="Rectangle 5"/>
+          <p:cNvSpPr/>
+          <p:nvPr/>
+        </p:nvSpPr>
+        <p:spPr>
+          <a:xfrm>
+            <a:off x="502920" y="6309360"/>
+            <a:ext cx="11201400" cy="27432"/>
+          </a:xfrm>
+          <a:prstGeom prst="rect">
+            <a:avLst/>
+          </a:prstGeom>
+          <a:solidFill>
+            <a:srgbClr val="1A86D6"/>
+          </a:solidFill>
+          <a:ln>
+            <a:noFill/>
+          </a:ln>
+        </p:spPr>
+        <p:style>
+          <a:lnRef idx="1">
+            <a:schemeClr val="accent1"/>
+          </a:lnRef>
+          <a:fillRef idx="3">
+            <a:schemeClr val="accent1"/>
+          </a:fillRef>
+          <a:effectRef idx="2">
+            <a:schemeClr val="accent1"/>
+          </a:effectRef>
+          <a:fontRef idx="minor">
+            <a:schemeClr val="lt1"/>
+          </a:fontRef>
+        </p:style>
+        <p:txBody>
+          <a:bodyPr rtlCol="0" anchor="ctr"/>
+          <a:lstStyle/>
+          <a:p>
+            <a:pPr algn="ctr"/>
+          </a:p>
+        </p:txBody>
+      </p:sp>
+      <p:sp>
+        <p:nvSpPr>
+          <p:cNvPr id="7" name="TextBox 6"/>
+          <p:cNvSpPr txBox="1"/>
+          <p:nvPr/>
+        </p:nvSpPr>
+        <p:spPr>
+          <a:xfrm>
+            <a:off x="502920" y="6400800"/>
+            <a:ext cx="6400800" cy="228600"/>
+          </a:xfrm>
+          <a:prstGeom prst="rect">
+            <a:avLst/>
+          </a:prstGeom>
+          <a:noFill/>
+        </p:spPr>
+        <p:txBody>
+          <a:bodyPr wrap="none">
+            <a:spAutoFit/>
+          </a:bodyPr>
+          <a:lstStyle/>
+          <a:p>
             <a:pPr>
-              <a:defRPr sz="1200">
-                <a:solidFill>
-                  <a:srgbClr val="5A5A5A"/>
+              <a:defRPr sz="1000">
+                <a:solidFill>
+                  <a:srgbClr val="5C5C5C"/>
                 </a:solidFill>
               </a:defRPr>
             </a:pPr>
             <a:r>
-              <a:t>Myriad | Privacy-first mindful habit tracking</a:t>
+              <a:t>Myriad</a:t>
+            </a:r>
+          </a:p>
+        </p:txBody>
+      </p:sp>
+      <p:sp>
+        <p:nvSpPr>
+          <p:cNvPr id="8" name="TextBox 7"/>
+          <p:cNvSpPr txBox="1"/>
+          <p:nvPr/>
+        </p:nvSpPr>
+        <p:spPr>
+          <a:xfrm>
+            <a:off x="9966960" y="6400800"/>
+            <a:ext cx="1737360" cy="228600"/>
+          </a:xfrm>
+          <a:prstGeom prst="rect">
+            <a:avLst/>
+          </a:prstGeom>
+          <a:noFill/>
+        </p:spPr>
+        <p:txBody>
+          <a:bodyPr wrap="none">
+            <a:spAutoFit/>
+          </a:bodyPr>
+          <a:lstStyle/>
+          <a:p>
+            <a:pPr algn="ctr">
+              <a:defRPr sz="1000">
+                <a:solidFill>
+                  <a:srgbClr val="5C5C5C"/>
+                </a:solidFill>
+              </a:defRPr>
+            </a:pPr>
+            <a:r>
+              <a:t>16 Apr 2026</a:t>
+            </a:r>
+          </a:p>
+        </p:txBody>
+      </p:sp>
+    </p:spTree>
+  </p:cSld>
+  <p:clrMapOvr>
+    <a:masterClrMapping/>
+  </p:clrMapOvr>
+</p:sld>
+</file>
+
+<file path=ppt/slides/slide8.xml><?xml version="1.0" encoding="utf-8"?>
+<p:sld xmlns:a="http://schemas.openxmlformats.org/drawingml/2006/main" xmlns:p="http://schemas.openxmlformats.org/presentationml/2006/main" xmlns:r="http://schemas.openxmlformats.org/officeDocument/2006/relationships">
+  <p:cSld>
+    <p:bg>
+      <p:bgPr>
+        <a:solidFill>
+          <a:srgbClr val="F4F8FC"/>
+        </a:solidFill>
+        <a:effectLst/>
+      </p:bgPr>
+    </p:bg>
+    <p:spTree>
+      <p:nvGrpSpPr>
+        <p:cNvPr id="1" name=""/>
+        <p:cNvGrpSpPr/>
+        <p:nvPr/>
+      </p:nvGrpSpPr>
+      <p:grpSpPr/>
+      <p:sp>
+        <p:nvSpPr>
+          <p:cNvPr id="2" name="TextBox 1"/>
+          <p:cNvSpPr txBox="1"/>
+          <p:nvPr/>
+        </p:nvSpPr>
+        <p:spPr>
+          <a:xfrm>
+            <a:off x="502920" y="320040"/>
+            <a:ext cx="11155680" cy="731520"/>
+          </a:xfrm>
+          <a:prstGeom prst="rect">
+            <a:avLst/>
+          </a:prstGeom>
+          <a:noFill/>
+        </p:spPr>
+        <p:txBody>
+          <a:bodyPr wrap="none">
+            <a:spAutoFit/>
+          </a:bodyPr>
+          <a:lstStyle/>
+          <a:p>
+            <a:r>
+              <a:rPr sz="3400" b="1">
+                <a:solidFill>
+                  <a:srgbClr val="0D2A3E"/>
+                </a:solidFill>
+              </a:rPr>
+              <a:t>Thank You</a:t>
+            </a:r>
+          </a:p>
+        </p:txBody>
+      </p:sp>
+      <p:sp>
+        <p:nvSpPr>
+          <p:cNvPr id="3" name="TextBox 2"/>
+          <p:cNvSpPr txBox="1"/>
+          <p:nvPr/>
+        </p:nvSpPr>
+        <p:spPr>
+          <a:xfrm>
+            <a:off x="868680" y="2011680"/>
+            <a:ext cx="6400800" cy="5303520"/>
+          </a:xfrm>
+          <a:prstGeom prst="rect">
+            <a:avLst/>
+          </a:prstGeom>
+          <a:noFill/>
+        </p:spPr>
+        <p:txBody>
+          <a:bodyPr wrap="square">
+            <a:spAutoFit/>
+          </a:bodyPr>
+          <a:lstStyle/>
+          <a:p>
+            <a:pPr>
+              <a:spcAft>
+                <a:spcPts val="1000"/>
+              </a:spcAft>
+              <a:defRPr sz="2600">
+                <a:solidFill>
+                  <a:srgbClr val="2D2D2D"/>
+                </a:solidFill>
+              </a:defRPr>
+            </a:pPr>
+            <a:r>
+              <a:t>Questions and feedback</a:t>
+            </a:r>
+          </a:p>
+          <a:p>
+            <a:pPr>
+              <a:spcAft>
+                <a:spcPts val="1000"/>
+              </a:spcAft>
+              <a:defRPr sz="2600">
+                <a:solidFill>
+                  <a:srgbClr val="2D2D2D"/>
+                </a:solidFill>
+              </a:defRPr>
+            </a:pPr>
+            <a:r>
+              <a:t>Artifacts, source, and media are included for reproducibility.</a:t>
+            </a:r>
+          </a:p>
+        </p:txBody>
+      </p:sp>
+      <p:sp>
+        <p:nvSpPr>
+          <p:cNvPr id="4" name="Rectangle 3"/>
+          <p:cNvSpPr/>
+          <p:nvPr/>
+        </p:nvSpPr>
+        <p:spPr>
+          <a:xfrm>
+            <a:off x="502920" y="6309360"/>
+            <a:ext cx="11201400" cy="27432"/>
+          </a:xfrm>
+          <a:prstGeom prst="rect">
+            <a:avLst/>
+          </a:prstGeom>
+          <a:solidFill>
+            <a:srgbClr val="1A86D6"/>
+          </a:solidFill>
+          <a:ln>
+            <a:noFill/>
+          </a:ln>
+        </p:spPr>
+        <p:style>
+          <a:lnRef idx="1">
+            <a:schemeClr val="accent1"/>
+          </a:lnRef>
+          <a:fillRef idx="3">
+            <a:schemeClr val="accent1"/>
+          </a:fillRef>
+          <a:effectRef idx="2">
+            <a:schemeClr val="accent1"/>
+          </a:effectRef>
+          <a:fontRef idx="minor">
+            <a:schemeClr val="lt1"/>
+          </a:fontRef>
+        </p:style>
+        <p:txBody>
+          <a:bodyPr rtlCol="0" anchor="ctr"/>
+          <a:lstStyle/>
+          <a:p>
+            <a:pPr algn="ctr"/>
+          </a:p>
+        </p:txBody>
+      </p:sp>
+      <p:sp>
+        <p:nvSpPr>
+          <p:cNvPr id="5" name="TextBox 4"/>
+          <p:cNvSpPr txBox="1"/>
+          <p:nvPr/>
+        </p:nvSpPr>
+        <p:spPr>
+          <a:xfrm>
+            <a:off x="502920" y="6400800"/>
+            <a:ext cx="6400800" cy="228600"/>
+          </a:xfrm>
+          <a:prstGeom prst="rect">
+            <a:avLst/>
+          </a:prstGeom>
+          <a:noFill/>
+        </p:spPr>
+        <p:txBody>
+          <a:bodyPr wrap="none">
+            <a:spAutoFit/>
+          </a:bodyPr>
+          <a:lstStyle/>
+          <a:p>
+            <a:pPr>
+              <a:defRPr sz="1000">
+                <a:solidFill>
+                  <a:srgbClr val="5C5C5C"/>
+                </a:solidFill>
+              </a:defRPr>
+            </a:pPr>
+            <a:r>
+              <a:t>Myriad</a:t>
             </a:r>
           </a:p>
         </p:txBody>
@@ -6081,8 +5625,8 @@
         </p:nvSpPr>
         <p:spPr>
           <a:xfrm>
-            <a:off x="8869680" y="6355080"/>
-            <a:ext cx="2651760" cy="365760"/>
+            <a:off x="9966960" y="6400800"/>
+            <a:ext cx="1737360" cy="228600"/>
           </a:xfrm>
           <a:prstGeom prst="rect">
             <a:avLst/>
@@ -6096,14 +5640,14 @@
           <a:lstStyle/>
           <a:p>
             <a:pPr algn="ctr">
-              <a:defRPr sz="1200">
-                <a:solidFill>
-                  <a:srgbClr val="5A5A5A"/>
+              <a:defRPr sz="1000">
+                <a:solidFill>
+                  <a:srgbClr val="5C5C5C"/>
                 </a:solidFill>
               </a:defRPr>
             </a:pPr>
             <a:r>
-              <a:t>15 Apr 2026</a:t>
+              <a:t>16 Apr 2026</a:t>
             </a:r>
           </a:p>
         </p:txBody>

</xml_diff>